<commit_message>
Expand next-steps slides with concrete methodology, grow to 34 slides
Findings section grew from 1 to 2 slides: each of the 5 items now gets
a fuller explanation (what it is, why it matters), including the
clearer price-outlier wording. The new-analysis section grew from 1
to 4 slides, one per item, each now states why it's needed and an
explicit "what we will actually do" method (e.g. the market-placement
check specifies testing against region and district area at the
district level; the source-agreement check specifies the exact
restriction, thresholds, and robustness checks it will need, and
reports the informal first-pass numbers already run as preliminary,
not final).

Re-validated with qa_geometry.py: 34 slides, 0 issues after fixing one
new label/stat/description overlap on the findings slide.
</commit_message>
<xml_diff>
--- a/weekly_meetings/2026_08_17_slides.pptx
+++ b/weekly_meetings/2026_08_17_slides.pptx
@@ -35,9 +35,13 @@
     <p:sldId id="283" r:id="rId29"/>
     <p:sldId id="284" r:id="rId30"/>
     <p:sldId id="285" r:id="rId31"/>
+    <p:sldId id="286" r:id="rId32"/>
+    <p:sldId id="287" r:id="rId33"/>
+    <p:sldId id="288" r:id="rId34"/>
+    <p:sldId id="289" r:id="rId35"/>
   </p:sldIdLst>
   <p:notesMasterIdLst>
-    <p:notesMasterId r:id="rId32"/>
+    <p:notesMasterId r:id="rId36"/>
   </p:notesMasterIdLst>
   <p:sldSz cx="12192000" cy="6858000"/>
   <p:notesSz cx="6858000" cy="12192000"/>
@@ -2579,6 +2583,358 @@
             <a:fld id="{F7021451-1387-4CA6-816F-3879F97B5CBC}" type="slidenum">
               <a:rPr lang="en-US"/>
               <a:t>30</a:t>
+            </a:fld>
+            <a:endParaRPr lang="en-US"/>
+          </a:p>
+        </p:txBody>
+      </p:sp>
+    </p:spTree>
+    <p:extLst>
+      <p:ext uri="{BB962C8B-B14F-4D97-AF65-F5344CB8AC3E}">
+        <p14:creationId xmlns:p14="http://schemas.microsoft.com/office/powerpoint/2010/main" val="1024086991"/>
+      </p:ext>
+    </p:extLst>
+  </p:cSld>
+  <p:clrMapOvr>
+    <a:masterClrMapping/>
+  </p:clrMapOvr>
+</p:notes>
+</file>
+
+<file path=ppt/notesSlides/notesSlide31.xml><?xml version="1.0" encoding="utf-8"?>
+<p:notes xmlns:a="http://schemas.openxmlformats.org/drawingml/2006/main" xmlns:r="http://schemas.openxmlformats.org/officeDocument/2006/relationships" xmlns:p="http://schemas.openxmlformats.org/presentationml/2006/main">
+  <p:cSld>
+    <p:spTree>
+      <p:nvGrpSpPr>
+        <p:cNvPr id="1" name=""/>
+        <p:cNvGrpSpPr/>
+        <p:nvPr/>
+      </p:nvGrpSpPr>
+      <p:grpSpPr>
+        <a:xfrm>
+          <a:off x="0" y="0"/>
+          <a:ext cx="0" cy="0"/>
+          <a:chOff x="0" y="0"/>
+          <a:chExt cx="0" cy="0"/>
+        </a:xfrm>
+      </p:grpSpPr>
+      <p:sp>
+        <p:nvSpPr>
+          <p:cNvPr id="2" name="Slide Image Placeholder 1"/>
+          <p:cNvSpPr>
+            <a:spLocks noGrp="1" noRot="1" noChangeAspect="1"/>
+          </p:cNvSpPr>
+          <p:nvPr>
+            <p:ph type="sldImg"/>
+          </p:nvPr>
+        </p:nvSpPr>
+        <p:spPr/>
+      </p:sp>
+      <p:sp>
+        <p:nvSpPr>
+          <p:cNvPr id="3" name="Notes Placeholder 2"/>
+          <p:cNvSpPr>
+            <a:spLocks noGrp="1"/>
+          </p:cNvSpPr>
+          <p:nvPr>
+            <p:ph type="body" idx="1"/>
+          </p:nvPr>
+        </p:nvSpPr>
+        <p:spPr/>
+        <p:txBody>
+          <a:bodyPr/>
+          <a:lstStyle/>
+          <a:p>
+            <a:r>
+              <a:rPr lang="en-US" dirty="0"/>
+              <a:t/>
+            </a:r>
+            <a:endParaRPr lang="en-US" dirty="0"/>
+          </a:p>
+        </p:txBody>
+      </p:sp>
+      <p:sp>
+        <p:nvSpPr>
+          <p:cNvPr id="4" name="Slide Number Placeholder 3"/>
+          <p:cNvSpPr>
+            <a:spLocks noGrp="1"/>
+          </p:cNvSpPr>
+          <p:nvPr>
+            <p:ph type="sldNum" sz="quarter" idx="10"/>
+          </p:nvPr>
+        </p:nvSpPr>
+        <p:spPr/>
+        <p:txBody>
+          <a:bodyPr/>
+          <a:lstStyle/>
+          <a:p>
+            <a:fld id="{F7021451-1387-4CA6-816F-3879F97B5CBC}" type="slidenum">
+              <a:rPr lang="en-US"/>
+              <a:t>31</a:t>
+            </a:fld>
+            <a:endParaRPr lang="en-US"/>
+          </a:p>
+        </p:txBody>
+      </p:sp>
+    </p:spTree>
+    <p:extLst>
+      <p:ext uri="{BB962C8B-B14F-4D97-AF65-F5344CB8AC3E}">
+        <p14:creationId xmlns:p14="http://schemas.microsoft.com/office/powerpoint/2010/main" val="1024086991"/>
+      </p:ext>
+    </p:extLst>
+  </p:cSld>
+  <p:clrMapOvr>
+    <a:masterClrMapping/>
+  </p:clrMapOvr>
+</p:notes>
+</file>
+
+<file path=ppt/notesSlides/notesSlide32.xml><?xml version="1.0" encoding="utf-8"?>
+<p:notes xmlns:a="http://schemas.openxmlformats.org/drawingml/2006/main" xmlns:r="http://schemas.openxmlformats.org/officeDocument/2006/relationships" xmlns:p="http://schemas.openxmlformats.org/presentationml/2006/main">
+  <p:cSld>
+    <p:spTree>
+      <p:nvGrpSpPr>
+        <p:cNvPr id="1" name=""/>
+        <p:cNvGrpSpPr/>
+        <p:nvPr/>
+      </p:nvGrpSpPr>
+      <p:grpSpPr>
+        <a:xfrm>
+          <a:off x="0" y="0"/>
+          <a:ext cx="0" cy="0"/>
+          <a:chOff x="0" y="0"/>
+          <a:chExt cx="0" cy="0"/>
+        </a:xfrm>
+      </p:grpSpPr>
+      <p:sp>
+        <p:nvSpPr>
+          <p:cNvPr id="2" name="Slide Image Placeholder 1"/>
+          <p:cNvSpPr>
+            <a:spLocks noGrp="1" noRot="1" noChangeAspect="1"/>
+          </p:cNvSpPr>
+          <p:nvPr>
+            <p:ph type="sldImg"/>
+          </p:nvPr>
+        </p:nvSpPr>
+        <p:spPr/>
+      </p:sp>
+      <p:sp>
+        <p:nvSpPr>
+          <p:cNvPr id="3" name="Notes Placeholder 2"/>
+          <p:cNvSpPr>
+            <a:spLocks noGrp="1"/>
+          </p:cNvSpPr>
+          <p:nvPr>
+            <p:ph type="body" idx="1"/>
+          </p:nvPr>
+        </p:nvSpPr>
+        <p:spPr/>
+        <p:txBody>
+          <a:bodyPr/>
+          <a:lstStyle/>
+          <a:p>
+            <a:r>
+              <a:rPr lang="en-US" dirty="0"/>
+              <a:t/>
+            </a:r>
+            <a:endParaRPr lang="en-US" dirty="0"/>
+          </a:p>
+        </p:txBody>
+      </p:sp>
+      <p:sp>
+        <p:nvSpPr>
+          <p:cNvPr id="4" name="Slide Number Placeholder 3"/>
+          <p:cNvSpPr>
+            <a:spLocks noGrp="1"/>
+          </p:cNvSpPr>
+          <p:nvPr>
+            <p:ph type="sldNum" sz="quarter" idx="10"/>
+          </p:nvPr>
+        </p:nvSpPr>
+        <p:spPr/>
+        <p:txBody>
+          <a:bodyPr/>
+          <a:lstStyle/>
+          <a:p>
+            <a:fld id="{F7021451-1387-4CA6-816F-3879F97B5CBC}" type="slidenum">
+              <a:rPr lang="en-US"/>
+              <a:t>32</a:t>
+            </a:fld>
+            <a:endParaRPr lang="en-US"/>
+          </a:p>
+        </p:txBody>
+      </p:sp>
+    </p:spTree>
+    <p:extLst>
+      <p:ext uri="{BB962C8B-B14F-4D97-AF65-F5344CB8AC3E}">
+        <p14:creationId xmlns:p14="http://schemas.microsoft.com/office/powerpoint/2010/main" val="1024086991"/>
+      </p:ext>
+    </p:extLst>
+  </p:cSld>
+  <p:clrMapOvr>
+    <a:masterClrMapping/>
+  </p:clrMapOvr>
+</p:notes>
+</file>
+
+<file path=ppt/notesSlides/notesSlide33.xml><?xml version="1.0" encoding="utf-8"?>
+<p:notes xmlns:a="http://schemas.openxmlformats.org/drawingml/2006/main" xmlns:r="http://schemas.openxmlformats.org/officeDocument/2006/relationships" xmlns:p="http://schemas.openxmlformats.org/presentationml/2006/main">
+  <p:cSld>
+    <p:spTree>
+      <p:nvGrpSpPr>
+        <p:cNvPr id="1" name=""/>
+        <p:cNvGrpSpPr/>
+        <p:nvPr/>
+      </p:nvGrpSpPr>
+      <p:grpSpPr>
+        <a:xfrm>
+          <a:off x="0" y="0"/>
+          <a:ext cx="0" cy="0"/>
+          <a:chOff x="0" y="0"/>
+          <a:chExt cx="0" cy="0"/>
+        </a:xfrm>
+      </p:grpSpPr>
+      <p:sp>
+        <p:nvSpPr>
+          <p:cNvPr id="2" name="Slide Image Placeholder 1"/>
+          <p:cNvSpPr>
+            <a:spLocks noGrp="1" noRot="1" noChangeAspect="1"/>
+          </p:cNvSpPr>
+          <p:nvPr>
+            <p:ph type="sldImg"/>
+          </p:nvPr>
+        </p:nvSpPr>
+        <p:spPr/>
+      </p:sp>
+      <p:sp>
+        <p:nvSpPr>
+          <p:cNvPr id="3" name="Notes Placeholder 2"/>
+          <p:cNvSpPr>
+            <a:spLocks noGrp="1"/>
+          </p:cNvSpPr>
+          <p:nvPr>
+            <p:ph type="body" idx="1"/>
+          </p:nvPr>
+        </p:nvSpPr>
+        <p:spPr/>
+        <p:txBody>
+          <a:bodyPr/>
+          <a:lstStyle/>
+          <a:p>
+            <a:r>
+              <a:rPr lang="en-US" dirty="0"/>
+              <a:t/>
+            </a:r>
+            <a:endParaRPr lang="en-US" dirty="0"/>
+          </a:p>
+        </p:txBody>
+      </p:sp>
+      <p:sp>
+        <p:nvSpPr>
+          <p:cNvPr id="4" name="Slide Number Placeholder 3"/>
+          <p:cNvSpPr>
+            <a:spLocks noGrp="1"/>
+          </p:cNvSpPr>
+          <p:nvPr>
+            <p:ph type="sldNum" sz="quarter" idx="10"/>
+          </p:nvPr>
+        </p:nvSpPr>
+        <p:spPr/>
+        <p:txBody>
+          <a:bodyPr/>
+          <a:lstStyle/>
+          <a:p>
+            <a:fld id="{F7021451-1387-4CA6-816F-3879F97B5CBC}" type="slidenum">
+              <a:rPr lang="en-US"/>
+              <a:t>33</a:t>
+            </a:fld>
+            <a:endParaRPr lang="en-US"/>
+          </a:p>
+        </p:txBody>
+      </p:sp>
+    </p:spTree>
+    <p:extLst>
+      <p:ext uri="{BB962C8B-B14F-4D97-AF65-F5344CB8AC3E}">
+        <p14:creationId xmlns:p14="http://schemas.microsoft.com/office/powerpoint/2010/main" val="1024086991"/>
+      </p:ext>
+    </p:extLst>
+  </p:cSld>
+  <p:clrMapOvr>
+    <a:masterClrMapping/>
+  </p:clrMapOvr>
+</p:notes>
+</file>
+
+<file path=ppt/notesSlides/notesSlide34.xml><?xml version="1.0" encoding="utf-8"?>
+<p:notes xmlns:a="http://schemas.openxmlformats.org/drawingml/2006/main" xmlns:r="http://schemas.openxmlformats.org/officeDocument/2006/relationships" xmlns:p="http://schemas.openxmlformats.org/presentationml/2006/main">
+  <p:cSld>
+    <p:spTree>
+      <p:nvGrpSpPr>
+        <p:cNvPr id="1" name=""/>
+        <p:cNvGrpSpPr/>
+        <p:nvPr/>
+      </p:nvGrpSpPr>
+      <p:grpSpPr>
+        <a:xfrm>
+          <a:off x="0" y="0"/>
+          <a:ext cx="0" cy="0"/>
+          <a:chOff x="0" y="0"/>
+          <a:chExt cx="0" cy="0"/>
+        </a:xfrm>
+      </p:grpSpPr>
+      <p:sp>
+        <p:nvSpPr>
+          <p:cNvPr id="2" name="Slide Image Placeholder 1"/>
+          <p:cNvSpPr>
+            <a:spLocks noGrp="1" noRot="1" noChangeAspect="1"/>
+          </p:cNvSpPr>
+          <p:nvPr>
+            <p:ph type="sldImg"/>
+          </p:nvPr>
+        </p:nvSpPr>
+        <p:spPr/>
+      </p:sp>
+      <p:sp>
+        <p:nvSpPr>
+          <p:cNvPr id="3" name="Notes Placeholder 2"/>
+          <p:cNvSpPr>
+            <a:spLocks noGrp="1"/>
+          </p:cNvSpPr>
+          <p:nvPr>
+            <p:ph type="body" idx="1"/>
+          </p:nvPr>
+        </p:nvSpPr>
+        <p:spPr/>
+        <p:txBody>
+          <a:bodyPr/>
+          <a:lstStyle/>
+          <a:p>
+            <a:r>
+              <a:rPr lang="en-US" dirty="0"/>
+              <a:t/>
+            </a:r>
+            <a:endParaRPr lang="en-US" dirty="0"/>
+          </a:p>
+        </p:txBody>
+      </p:sp>
+      <p:sp>
+        <p:nvSpPr>
+          <p:cNvPr id="4" name="Slide Number Placeholder 3"/>
+          <p:cNvSpPr>
+            <a:spLocks noGrp="1"/>
+          </p:cNvSpPr>
+          <p:nvPr>
+            <p:ph type="sldNum" sz="quarter" idx="10"/>
+          </p:nvPr>
+        </p:nvSpPr>
+        <p:spPr/>
+        <p:txBody>
+          <a:bodyPr/>
+          <a:lstStyle/>
+          <a:p>
+            <a:fld id="{F7021451-1387-4CA6-816F-3879F97B5CBC}" type="slidenum">
+              <a:rPr lang="en-US"/>
+              <a:t>34</a:t>
             </a:fld>
             <a:endParaRPr lang="en-US"/>
           </a:p>
@@ -18551,61 +18907,22 @@
       </p:sp>
       <p:sp>
         <p:nvSpPr>
-          <p:cNvPr id="4" name="Text 2"/>
-          <p:cNvSpPr/>
-          <p:nvPr/>
-        </p:nvSpPr>
-        <p:spPr>
-          <a:xfrm>
-            <a:off x="566928" y="1426464"/>
-            <a:ext cx="11027664" cy="365760"/>
-          </a:xfrm>
-          <a:prstGeom prst="rect">
-            <a:avLst/>
-          </a:prstGeom>
-          <a:noFill/>
-          <a:ln/>
-        </p:spPr>
-        <p:txBody>
-          <a:bodyPr wrap="square" lIns="0" tIns="0" rIns="0" bIns="0" rtlCol="0" anchor="ctr"/>
-          <a:lstStyle/>
-          <a:p>
-            <a:pPr indent="0" marL="0">
-              <a:buNone/>
-            </a:pPr>
-            <a:r>
-              <a:rPr lang="en-US" sz="1200" i="1" dirty="0">
-                <a:solidFill>
-                  <a:srgbClr val="7A6E68"/>
-                </a:solidFill>
-                <a:latin typeface="Calibri" pitchFamily="34" charset="0"/>
-                <a:ea typeface="Calibri" pitchFamily="34" charset="-122"/>
-                <a:cs typeface="Calibri" pitchFamily="34" charset="-120"/>
-              </a:rPr>
-              <a:t>These five were investigated and verified this week. Nothing further needs to be computed; each is a finished result waiting to be written into the dissertation.</a:t>
-            </a:r>
-            <a:endParaRPr lang="en-US" sz="1200" dirty="0"/>
-          </a:p>
-        </p:txBody>
-      </p:sp>
-      <p:sp>
-        <p:nvSpPr>
-          <p:cNvPr id="5" name="Shape 3"/>
-          <p:cNvSpPr/>
-          <p:nvPr/>
-        </p:nvSpPr>
-        <p:spPr>
-          <a:xfrm>
-            <a:off x="566928" y="1920240"/>
-            <a:ext cx="5404104" cy="1316736"/>
+          <p:cNvPr id="4" name="Shape 2"/>
+          <p:cNvSpPr/>
+          <p:nvPr/>
+        </p:nvSpPr>
+        <p:spPr>
+          <a:xfrm>
+            <a:off x="566928" y="1463040"/>
+            <a:ext cx="11027664" cy="1554480"/>
           </a:xfrm>
           <a:prstGeom prst="roundRect">
             <a:avLst>
-              <a:gd name="adj" fmla="val 4167"/>
+              <a:gd name="adj" fmla="val 3529"/>
             </a:avLst>
           </a:prstGeom>
           <a:solidFill>
-            <a:srgbClr val="E7E8D1"/>
+            <a:srgbClr val="F7F5F1"/>
           </a:solidFill>
           <a:ln/>
           <a:effectLst>
@@ -18619,30 +18936,33 @@
       </p:sp>
       <p:sp>
         <p:nvSpPr>
-          <p:cNvPr id="6" name="Text 4"/>
-          <p:cNvSpPr/>
-          <p:nvPr/>
-        </p:nvSpPr>
-        <p:spPr>
-          <a:xfrm>
-            <a:off x="768096" y="2048256"/>
-            <a:ext cx="5001768" cy="310896"/>
-          </a:xfrm>
-          <a:prstGeom prst="rect">
-            <a:avLst/>
-          </a:prstGeom>
-          <a:noFill/>
-          <a:ln/>
-        </p:spPr>
-        <p:txBody>
-          <a:bodyPr wrap="square" lIns="0" tIns="0" rIns="0" bIns="0" rtlCol="0" anchor="ctr"/>
-          <a:lstStyle/>
-          <a:p>
-            <a:pPr indent="0" marL="0">
-              <a:buNone/>
-            </a:pPr>
-            <a:r>
-              <a:rPr lang="en-US" sz="1200" b="1" dirty="0">
+          <p:cNvPr id="5" name="Text 3"/>
+          <p:cNvSpPr/>
+          <p:nvPr/>
+        </p:nvSpPr>
+        <p:spPr>
+          <a:xfrm>
+            <a:off x="804672" y="1591056"/>
+            <a:ext cx="2377440" cy="1280160"/>
+          </a:xfrm>
+          <a:prstGeom prst="rect">
+            <a:avLst/>
+          </a:prstGeom>
+          <a:noFill/>
+          <a:ln/>
+        </p:spPr>
+        <p:txBody>
+          <a:bodyPr wrap="square" lIns="0" tIns="0" rIns="0" bIns="0" rtlCol="0" anchor="ctr"/>
+          <a:lstStyle/>
+          <a:p>
+            <a:pPr indent="0" marL="0">
+              <a:lnSpc>
+                <a:spcPts val="1600"/>
+              </a:lnSpc>
+              <a:buNone/>
+            </a:pPr>
+            <a:r>
+              <a:rPr lang="en-US" sz="1300" b="1" dirty="0">
                 <a:solidFill>
                   <a:srgbClr val="2B2523"/>
                 </a:solidFill>
@@ -18652,7 +18972,46 @@
               </a:rPr>
               <a:t>Conflict location precision</a:t>
             </a:r>
-            <a:endParaRPr lang="en-US" sz="1200" dirty="0"/>
+            <a:endParaRPr lang="en-US" sz="1300" dirty="0"/>
+          </a:p>
+        </p:txBody>
+      </p:sp>
+      <p:sp>
+        <p:nvSpPr>
+          <p:cNvPr id="6" name="Text 4"/>
+          <p:cNvSpPr/>
+          <p:nvPr/>
+        </p:nvSpPr>
+        <p:spPr>
+          <a:xfrm>
+            <a:off x="3246120" y="1591056"/>
+            <a:ext cx="1554480" cy="1280160"/>
+          </a:xfrm>
+          <a:prstGeom prst="rect">
+            <a:avLst/>
+          </a:prstGeom>
+          <a:noFill/>
+          <a:ln/>
+        </p:spPr>
+        <p:txBody>
+          <a:bodyPr wrap="square" lIns="0" tIns="0" rIns="0" bIns="0" rtlCol="0" anchor="ctr"/>
+          <a:lstStyle/>
+          <a:p>
+            <a:pPr indent="0" marL="0">
+              <a:buNone/>
+            </a:pPr>
+            <a:r>
+              <a:rPr lang="en-US" sz="1700" b="1" dirty="0">
+                <a:solidFill>
+                  <a:srgbClr val="B85042"/>
+                </a:solidFill>
+                <a:latin typeface="Cambria" pitchFamily="34" charset="0"/>
+                <a:ea typeface="Cambria" pitchFamily="34" charset="-122"/>
+                <a:cs typeface="Cambria" pitchFamily="34" charset="-120"/>
+              </a:rPr>
+              <a:t>22.4%</a:t>
+            </a:r>
+            <a:endParaRPr lang="en-US" sz="1700" dirty="0"/>
           </a:p>
         </p:txBody>
       </p:sp>
@@ -18664,8 +19023,8 @@
         </p:nvSpPr>
         <p:spPr>
           <a:xfrm>
-            <a:off x="768096" y="2377440"/>
-            <a:ext cx="5001768" cy="804672"/>
+            <a:off x="5029200" y="1591056"/>
+            <a:ext cx="6327648" cy="1280160"/>
           </a:xfrm>
           <a:prstGeom prst="rect">
             <a:avLst/>
@@ -18679,22 +19038,22 @@
           <a:p>
             <a:pPr indent="0" marL="0">
               <a:lnSpc>
-                <a:spcPts val="1300"/>
+                <a:spcPts val="1400"/>
               </a:lnSpc>
               <a:buNone/>
             </a:pPr>
             <a:r>
-              <a:rPr lang="en-US" sz="1000" dirty="0">
-                <a:solidFill>
-                  <a:srgbClr val="2B2523"/>
+              <a:rPr lang="en-US" sz="1050" dirty="0">
+                <a:solidFill>
+                  <a:srgbClr val="7A6E68"/>
                 </a:solidFill>
                 <a:latin typeface="Calibri" pitchFamily="34" charset="0"/>
                 <a:ea typeface="Calibri" pitchFamily="34" charset="-122"/>
                 <a:cs typeface="Calibri" pitchFamily="34" charset="-120"/>
               </a:rPr>
-              <a:t>22.4% of Somalia's 2024 conflict events are only approximately located, not pinned to an exact site, and it varies sharply by district (0-69%).</a:t>
-            </a:r>
-            <a:endParaRPr lang="en-US" sz="1000" dirty="0"/>
+              <a:t>of Somalia's 2024 conflict events (772 of 3,448) are only approximately located, not pinned to an exact site. ACLED codes this itself: some events are placed at the nearest known town rather than their real one. It varies sharply by district, from 0% to 69%, with no simple link to how many events a district has.</a:t>
+            </a:r>
+            <a:endParaRPr lang="en-US" sz="1050" dirty="0"/>
           </a:p>
         </p:txBody>
       </p:sp>
@@ -18706,16 +19065,16 @@
         </p:nvSpPr>
         <p:spPr>
           <a:xfrm>
-            <a:off x="6190488" y="1920240"/>
-            <a:ext cx="5404104" cy="1316736"/>
+            <a:off x="566928" y="3145536"/>
+            <a:ext cx="11027664" cy="1554480"/>
           </a:xfrm>
           <a:prstGeom prst="roundRect">
             <a:avLst>
-              <a:gd name="adj" fmla="val 4167"/>
+              <a:gd name="adj" fmla="val 3529"/>
             </a:avLst>
           </a:prstGeom>
           <a:solidFill>
-            <a:srgbClr val="E7E8D1"/>
+            <a:srgbClr val="F7F5F1"/>
           </a:solidFill>
           <a:ln/>
           <a:effectLst>
@@ -18735,24 +19094,27 @@
         </p:nvSpPr>
         <p:spPr>
           <a:xfrm>
-            <a:off x="6391656" y="2048256"/>
-            <a:ext cx="5001768" cy="310896"/>
-          </a:xfrm>
-          <a:prstGeom prst="rect">
-            <a:avLst/>
-          </a:prstGeom>
-          <a:noFill/>
-          <a:ln/>
-        </p:spPr>
-        <p:txBody>
-          <a:bodyPr wrap="square" lIns="0" tIns="0" rIns="0" bIns="0" rtlCol="0" anchor="ctr"/>
-          <a:lstStyle/>
-          <a:p>
-            <a:pPr indent="0" marL="0">
-              <a:buNone/>
-            </a:pPr>
-            <a:r>
-              <a:rPr lang="en-US" sz="1200" b="1" dirty="0">
+            <a:off x="804672" y="3273552"/>
+            <a:ext cx="2377440" cy="1280160"/>
+          </a:xfrm>
+          <a:prstGeom prst="rect">
+            <a:avLst/>
+          </a:prstGeom>
+          <a:noFill/>
+          <a:ln/>
+        </p:spPr>
+        <p:txBody>
+          <a:bodyPr wrap="square" lIns="0" tIns="0" rIns="0" bIns="0" rtlCol="0" anchor="ctr"/>
+          <a:lstStyle/>
+          <a:p>
+            <a:pPr indent="0" marL="0">
+              <a:lnSpc>
+                <a:spcPts val="1600"/>
+              </a:lnSpc>
+              <a:buNone/>
+            </a:pPr>
+            <a:r>
+              <a:rPr lang="en-US" sz="1300" b="1" dirty="0">
                 <a:solidFill>
                   <a:srgbClr val="2B2523"/>
                 </a:solidFill>
@@ -18762,7 +19124,7 @@
               </a:rPr>
               <a:t>The market/PEWI gap, quantified</a:t>
             </a:r>
-            <a:endParaRPr lang="en-US" sz="1200" dirty="0"/>
+            <a:endParaRPr lang="en-US" sz="1300" dirty="0"/>
           </a:p>
         </p:txBody>
       </p:sp>
@@ -18774,8 +19136,47 @@
         </p:nvSpPr>
         <p:spPr>
           <a:xfrm>
-            <a:off x="6391656" y="2377440"/>
-            <a:ext cx="5001768" cy="804672"/>
+            <a:off x="3246120" y="3273552"/>
+            <a:ext cx="1554480" cy="1280160"/>
+          </a:xfrm>
+          <a:prstGeom prst="rect">
+            <a:avLst/>
+          </a:prstGeom>
+          <a:noFill/>
+          <a:ln/>
+        </p:spPr>
+        <p:txBody>
+          <a:bodyPr wrap="square" lIns="0" tIns="0" rIns="0" bIns="0" rtlCol="0" anchor="ctr"/>
+          <a:lstStyle/>
+          <a:p>
+            <a:pPr indent="0" marL="0">
+              <a:buNone/>
+            </a:pPr>
+            <a:r>
+              <a:rPr lang="en-US" sz="1700" b="1" dirty="0">
+                <a:solidFill>
+                  <a:srgbClr val="B85042"/>
+                </a:solidFill>
+                <a:latin typeface="Cambria" pitchFamily="34" charset="0"/>
+                <a:ea typeface="Cambria" pitchFamily="34" charset="-122"/>
+                <a:cs typeface="Cambria" pitchFamily="34" charset="-120"/>
+              </a:rPr>
+              <a:t>147 of 1,676</a:t>
+            </a:r>
+            <a:endParaRPr lang="en-US" sz="1700" dirty="0"/>
+          </a:p>
+        </p:txBody>
+      </p:sp>
+      <p:sp>
+        <p:nvSpPr>
+          <p:cNvPr id="11" name="Text 9"/>
+          <p:cNvSpPr/>
+          <p:nvPr/>
+        </p:nvSpPr>
+        <p:spPr>
+          <a:xfrm>
+            <a:off x="5029200" y="3273552"/>
+            <a:ext cx="6327648" cy="1280160"/>
           </a:xfrm>
           <a:prstGeom prst="rect">
             <a:avLst/>
@@ -18789,43 +19190,43 @@
           <a:p>
             <a:pPr indent="0" marL="0">
               <a:lnSpc>
-                <a:spcPts val="1300"/>
+                <a:spcPts val="1400"/>
               </a:lnSpc>
               <a:buNone/>
             </a:pPr>
             <a:r>
-              <a:rPr lang="en-US" sz="1000" dirty="0">
-                <a:solidFill>
-                  <a:srgbClr val="2B2523"/>
+              <a:rPr lang="en-US" sz="1050" dirty="0">
+                <a:solidFill>
+                  <a:srgbClr val="7A6E68"/>
                 </a:solidFill>
                 <a:latin typeface="Calibri" pitchFamily="34" charset="0"/>
                 <a:ea typeface="Calibri" pitchFamily="34" charset="-122"/>
                 <a:cs typeface="Calibri" pitchFamily="34" charset="-120"/>
               </a:rPr>
-              <a:t>147 of 1,676 basket-commodity price records (8.8%) have a price but no PEWI score, concentrated in 3 districts missing it all year.</a:t>
-            </a:r>
-            <a:endParaRPr lang="en-US" sz="1000" dirty="0"/>
-          </a:p>
-        </p:txBody>
-      </p:sp>
-      <p:sp>
-        <p:nvSpPr>
-          <p:cNvPr id="11" name="Shape 9"/>
-          <p:cNvSpPr/>
-          <p:nvPr/>
-        </p:nvSpPr>
-        <p:spPr>
-          <a:xfrm>
-            <a:off x="566928" y="3383280"/>
-            <a:ext cx="5404104" cy="1316736"/>
+              <a:t>basket-commodity price records (8.8%) have a real price on file but no PEWI score at all. Almost all of this sits in 3 districts (Rab Dhuure, Taleex, Xudun) missing it completely, every month, all year, which is why PEWI-based market coverage (43.1%) reads lower than price-based coverage (47.2%).</a:t>
+            </a:r>
+            <a:endParaRPr lang="en-US" sz="1050" dirty="0"/>
+          </a:p>
+        </p:txBody>
+      </p:sp>
+      <p:sp>
+        <p:nvSpPr>
+          <p:cNvPr id="12" name="Shape 10"/>
+          <p:cNvSpPr/>
+          <p:nvPr/>
+        </p:nvSpPr>
+        <p:spPr>
+          <a:xfrm>
+            <a:off x="566928" y="4828032"/>
+            <a:ext cx="11027664" cy="1554480"/>
           </a:xfrm>
           <a:prstGeom prst="roundRect">
             <a:avLst>
-              <a:gd name="adj" fmla="val 4167"/>
+              <a:gd name="adj" fmla="val 3529"/>
             </a:avLst>
           </a:prstGeom>
           <a:solidFill>
-            <a:srgbClr val="E7E8D1"/>
+            <a:srgbClr val="F7F5F1"/>
           </a:solidFill>
           <a:ln/>
           <a:effectLst>
@@ -18839,30 +19240,33 @@
       </p:sp>
       <p:sp>
         <p:nvSpPr>
-          <p:cNvPr id="12" name="Text 10"/>
-          <p:cNvSpPr/>
-          <p:nvPr/>
-        </p:nvSpPr>
-        <p:spPr>
-          <a:xfrm>
-            <a:off x="768096" y="3511296"/>
-            <a:ext cx="5001768" cy="310896"/>
-          </a:xfrm>
-          <a:prstGeom prst="rect">
-            <a:avLst/>
-          </a:prstGeom>
-          <a:noFill/>
-          <a:ln/>
-        </p:spPr>
-        <p:txBody>
-          <a:bodyPr wrap="square" lIns="0" tIns="0" rIns="0" bIns="0" rtlCol="0" anchor="ctr"/>
-          <a:lstStyle/>
-          <a:p>
-            <a:pPr indent="0" marL="0">
-              <a:buNone/>
-            </a:pPr>
-            <a:r>
-              <a:rPr lang="en-US" sz="1200" b="1" dirty="0">
+          <p:cNvPr id="13" name="Text 11"/>
+          <p:cNvSpPr/>
+          <p:nvPr/>
+        </p:nvSpPr>
+        <p:spPr>
+          <a:xfrm>
+            <a:off x="804672" y="4956048"/>
+            <a:ext cx="2377440" cy="1280160"/>
+          </a:xfrm>
+          <a:prstGeom prst="rect">
+            <a:avLst/>
+          </a:prstGeom>
+          <a:noFill/>
+          <a:ln/>
+        </p:spPr>
+        <p:txBody>
+          <a:bodyPr wrap="square" lIns="0" tIns="0" rIns="0" bIns="0" rtlCol="0" anchor="ctr"/>
+          <a:lstStyle/>
+          <a:p>
+            <a:pPr indent="0" marL="0">
+              <a:lnSpc>
+                <a:spcPts val="1600"/>
+              </a:lnSpc>
+              <a:buNone/>
+            </a:pPr>
+            <a:r>
+              <a:rPr lang="en-US" sz="1300" b="1" dirty="0">
                 <a:solidFill>
                   <a:srgbClr val="2B2523"/>
                 </a:solidFill>
@@ -18870,22 +19274,61 @@
                 <a:ea typeface="Cambria" pitchFamily="34" charset="-122"/>
                 <a:cs typeface="Cambria" pitchFamily="34" charset="-120"/>
               </a:rPr>
-              <a:t>Price outlier check</a:t>
-            </a:r>
-            <a:endParaRPr lang="en-US" sz="1200" dirty="0"/>
-          </a:p>
-        </p:txBody>
-      </p:sp>
-      <p:sp>
-        <p:nvSpPr>
-          <p:cNvPr id="13" name="Text 11"/>
-          <p:cNvSpPr/>
-          <p:nvPr/>
-        </p:nvSpPr>
-        <p:spPr>
-          <a:xfrm>
-            <a:off x="768096" y="3840480"/>
-            <a:ext cx="5001768" cy="804672"/>
+              <a:t>Price outlier check, came back clean</a:t>
+            </a:r>
+            <a:endParaRPr lang="en-US" sz="1300" dirty="0"/>
+          </a:p>
+        </p:txBody>
+      </p:sp>
+      <p:sp>
+        <p:nvSpPr>
+          <p:cNvPr id="14" name="Text 12"/>
+          <p:cNvSpPr/>
+          <p:nvPr/>
+        </p:nvSpPr>
+        <p:spPr>
+          <a:xfrm>
+            <a:off x="3246120" y="4956048"/>
+            <a:ext cx="1554480" cy="1280160"/>
+          </a:xfrm>
+          <a:prstGeom prst="rect">
+            <a:avLst/>
+          </a:prstGeom>
+          <a:noFill/>
+          <a:ln/>
+        </p:spPr>
+        <p:txBody>
+          <a:bodyPr wrap="square" lIns="0" tIns="0" rIns="0" bIns="0" rtlCol="0" anchor="ctr"/>
+          <a:lstStyle/>
+          <a:p>
+            <a:pPr indent="0" marL="0">
+              <a:buNone/>
+            </a:pPr>
+            <a:r>
+              <a:rPr lang="en-US" sz="1700" b="1" dirty="0">
+                <a:solidFill>
+                  <a:srgbClr val="B85042"/>
+                </a:solidFill>
+                <a:latin typeface="Cambria" pitchFamily="34" charset="0"/>
+                <a:ea typeface="Cambria" pitchFamily="34" charset="-122"/>
+                <a:cs typeface="Cambria" pitchFamily="34" charset="-120"/>
+              </a:rPr>
+              <a:t>0 issues</a:t>
+            </a:r>
+            <a:endParaRPr lang="en-US" sz="1700" dirty="0"/>
+          </a:p>
+        </p:txBody>
+      </p:sp>
+      <p:sp>
+        <p:nvSpPr>
+          <p:cNvPr id="15" name="Text 13"/>
+          <p:cNvSpPr/>
+          <p:nvPr/>
+        </p:nvSpPr>
+        <p:spPr>
+          <a:xfrm>
+            <a:off x="5029200" y="4956048"/>
+            <a:ext cx="6327648" cy="1280160"/>
           </a:xfrm>
           <a:prstGeom prst="rect">
             <a:avLst/>
@@ -18899,90 +19342,22 @@
           <a:p>
             <a:pPr indent="0" marL="0">
               <a:lnSpc>
-                <a:spcPts val="1300"/>
+                <a:spcPts val="1400"/>
               </a:lnSpc>
               <a:buNone/>
             </a:pPr>
             <a:r>
-              <a:rPr lang="en-US" sz="1000" dirty="0">
-                <a:solidFill>
-                  <a:srgbClr val="2B2523"/>
+              <a:rPr lang="en-US" sz="1050" dirty="0">
+                <a:solidFill>
+                  <a:srgbClr val="7A6E68"/>
                 </a:solidFill>
                 <a:latin typeface="Calibri" pitchFamily="34" charset="0"/>
                 <a:ea typeface="Calibri" pitchFamily="34" charset="-122"/>
                 <a:cs typeface="Calibri" pitchFamily="34" charset="-120"/>
               </a:rPr>
-              <a:t>Ran a check for implausible prices. Came back clean, nothing to report beyond confirming it was checked.</a:t>
-            </a:r>
-            <a:endParaRPr lang="en-US" sz="1000" dirty="0"/>
-          </a:p>
-        </p:txBody>
-      </p:sp>
-      <p:sp>
-        <p:nvSpPr>
-          <p:cNvPr id="14" name="Shape 12"/>
-          <p:cNvSpPr/>
-          <p:nvPr/>
-        </p:nvSpPr>
-        <p:spPr>
-          <a:xfrm>
-            <a:off x="6190488" y="3383280"/>
-            <a:ext cx="5404104" cy="1316736"/>
-          </a:xfrm>
-          <a:prstGeom prst="roundRect">
-            <a:avLst>
-              <a:gd name="adj" fmla="val 4167"/>
-            </a:avLst>
-          </a:prstGeom>
-          <a:solidFill>
-            <a:srgbClr val="E7E8D1"/>
-          </a:solidFill>
-          <a:ln/>
-          <a:effectLst>
-            <a:outerShdw sx="100000" sy="100000" kx="0" ky="0" algn="bl" rotWithShape="0" blurRad="76200" dist="381" dir="5400000">
-              <a:srgbClr val="000000">
-                <a:alpha val="8000"/>
-              </a:srgbClr>
-            </a:outerShdw>
-          </a:effectLst>
-        </p:spPr>
-      </p:sp>
-      <p:sp>
-        <p:nvSpPr>
-          <p:cNvPr id="15" name="Text 13"/>
-          <p:cNvSpPr/>
-          <p:nvPr/>
-        </p:nvSpPr>
-        <p:spPr>
-          <a:xfrm>
-            <a:off x="6391656" y="3511296"/>
-            <a:ext cx="5001768" cy="310896"/>
-          </a:xfrm>
-          <a:prstGeom prst="rect">
-            <a:avLst/>
-          </a:prstGeom>
-          <a:noFill/>
-          <a:ln/>
-        </p:spPr>
-        <p:txBody>
-          <a:bodyPr wrap="square" lIns="0" tIns="0" rIns="0" bIns="0" rtlCol="0" anchor="ctr"/>
-          <a:lstStyle/>
-          <a:p>
-            <a:pPr indent="0" marL="0">
-              <a:buNone/>
-            </a:pPr>
-            <a:r>
-              <a:rPr lang="en-US" sz="1200" b="1" dirty="0">
-                <a:solidFill>
-                  <a:srgbClr val="2B2523"/>
-                </a:solidFill>
-                <a:latin typeface="Cambria" pitchFamily="34" charset="0"/>
-                <a:ea typeface="Cambria" pitchFamily="34" charset="-122"/>
-                <a:cs typeface="Cambria" pitchFamily="34" charset="-120"/>
-              </a:rPr>
-              <a:t>Trend features miss more than prices</a:t>
-            </a:r>
-            <a:endParaRPr lang="en-US" sz="1200" dirty="0"/>
+              <a:t>checked every price in the four basket foods for values that looked broken, like a typo or a currency-conversion mistake, using a standard rule for spotting numbers that sit unusually far from the rest of the data. The handful flagged were all normal, believable prices, not errors. Rules out a real, easy-to-miss risk to the market data.</a:t>
+            </a:r>
+            <a:endParaRPr lang="en-US" sz="1050" dirty="0"/>
           </a:p>
         </p:txBody>
       </p:sp>
@@ -18994,215 +19369,34 @@
         </p:nvSpPr>
         <p:spPr>
           <a:xfrm>
-            <a:off x="6391656" y="3840480"/>
-            <a:ext cx="5001768" cy="804672"/>
-          </a:xfrm>
-          <a:prstGeom prst="rect">
-            <a:avLst/>
-          </a:prstGeom>
-          <a:noFill/>
-          <a:ln/>
-        </p:spPr>
-        <p:txBody>
-          <a:bodyPr wrap="square" lIns="0" tIns="0" rIns="0" bIns="0" rtlCol="0" anchor="ctr"/>
-          <a:lstStyle/>
-          <a:p>
-            <a:pPr indent="0" marL="0">
-              <a:lnSpc>
-                <a:spcPts val="1300"/>
-              </a:lnSpc>
-              <a:buNone/>
-            </a:pPr>
-            <a:r>
-              <a:rPr lang="en-US" sz="1000" dirty="0">
-                <a:solidFill>
-                  <a:srgbClr val="2B2523"/>
+            <a:off x="566928" y="6144768"/>
+            <a:ext cx="11027664" cy="237744"/>
+          </a:xfrm>
+          <a:prstGeom prst="rect">
+            <a:avLst/>
+          </a:prstGeom>
+          <a:noFill/>
+          <a:ln/>
+        </p:spPr>
+        <p:txBody>
+          <a:bodyPr wrap="square" lIns="0" tIns="0" rIns="0" bIns="0" rtlCol="0" anchor="ctr"/>
+          <a:lstStyle/>
+          <a:p>
+            <a:pPr indent="0" marL="0">
+              <a:buNone/>
+            </a:pPr>
+            <a:r>
+              <a:rPr lang="en-US" sz="900" i="1" dirty="0">
+                <a:solidFill>
+                  <a:srgbClr val="7A6E68"/>
                 </a:solidFill>
                 <a:latin typeface="Calibri" pitchFamily="34" charset="0"/>
                 <a:ea typeface="Calibri" pitchFamily="34" charset="-122"/>
                 <a:cs typeface="Calibri" pitchFamily="34" charset="-120"/>
               </a:rPr>
-              <a:t>The price-change features are missing 56.8% of the time, versus 52.8% for the prices they're built from, since a trend needs two consecutive months.</a:t>
-            </a:r>
-            <a:endParaRPr lang="en-US" sz="1000" dirty="0"/>
-          </a:p>
-        </p:txBody>
-      </p:sp>
-      <p:sp>
-        <p:nvSpPr>
-          <p:cNvPr id="17" name="Shape 15"/>
-          <p:cNvSpPr/>
-          <p:nvPr/>
-        </p:nvSpPr>
-        <p:spPr>
-          <a:xfrm>
-            <a:off x="566928" y="4846320"/>
-            <a:ext cx="5404104" cy="1316736"/>
-          </a:xfrm>
-          <a:prstGeom prst="roundRect">
-            <a:avLst>
-              <a:gd name="adj" fmla="val 4167"/>
-            </a:avLst>
-          </a:prstGeom>
-          <a:solidFill>
-            <a:srgbClr val="E7E8D1"/>
-          </a:solidFill>
-          <a:ln/>
-          <a:effectLst>
-            <a:outerShdw sx="100000" sy="100000" kx="0" ky="0" algn="bl" rotWithShape="0" blurRad="76200" dist="381" dir="5400000">
-              <a:srgbClr val="000000">
-                <a:alpha val="8000"/>
-              </a:srgbClr>
-            </a:outerShdw>
-          </a:effectLst>
-        </p:spPr>
-      </p:sp>
-      <p:sp>
-        <p:nvSpPr>
-          <p:cNvPr id="18" name="Text 16"/>
-          <p:cNvSpPr/>
-          <p:nvPr/>
-        </p:nvSpPr>
-        <p:spPr>
-          <a:xfrm>
-            <a:off x="768096" y="4974336"/>
-            <a:ext cx="5001768" cy="310896"/>
-          </a:xfrm>
-          <a:prstGeom prst="rect">
-            <a:avLst/>
-          </a:prstGeom>
-          <a:noFill/>
-          <a:ln/>
-        </p:spPr>
-        <p:txBody>
-          <a:bodyPr wrap="square" lIns="0" tIns="0" rIns="0" bIns="0" rtlCol="0" anchor="ctr"/>
-          <a:lstStyle/>
-          <a:p>
-            <a:pPr indent="0" marL="0">
-              <a:buNone/>
-            </a:pPr>
-            <a:r>
-              <a:rPr lang="en-US" sz="1200" b="1" dirty="0">
-                <a:solidFill>
-                  <a:srgbClr val="2B2523"/>
-                </a:solidFill>
-                <a:latin typeface="Cambria" pitchFamily="34" charset="0"/>
-                <a:ea typeface="Cambria" pitchFamily="34" charset="-122"/>
-                <a:cs typeface="Cambria" pitchFamily="34" charset="-120"/>
-              </a:rPr>
-              <a:t>"Whole basket or nothing" reporting</a:t>
-            </a:r>
-            <a:endParaRPr lang="en-US" sz="1200" dirty="0"/>
-          </a:p>
-        </p:txBody>
-      </p:sp>
-      <p:sp>
-        <p:nvSpPr>
-          <p:cNvPr id="19" name="Text 17"/>
-          <p:cNvSpPr/>
-          <p:nvPr/>
-        </p:nvSpPr>
-        <p:spPr>
-          <a:xfrm>
-            <a:off x="768096" y="5303520"/>
-            <a:ext cx="5001768" cy="804672"/>
-          </a:xfrm>
-          <a:prstGeom prst="rect">
-            <a:avLst/>
-          </a:prstGeom>
-          <a:noFill/>
-          <a:ln/>
-        </p:spPr>
-        <p:txBody>
-          <a:bodyPr wrap="square" lIns="0" tIns="0" rIns="0" bIns="0" rtlCol="0" anchor="ctr"/>
-          <a:lstStyle/>
-          <a:p>
-            <a:pPr indent="0" marL="0">
-              <a:lnSpc>
-                <a:spcPts val="1300"/>
-              </a:lnSpc>
-              <a:buNone/>
-            </a:pPr>
-            <a:r>
-              <a:rPr lang="en-US" sz="1000" dirty="0">
-                <a:solidFill>
-                  <a:srgbClr val="2B2523"/>
-                </a:solidFill>
-                <a:latin typeface="Calibri" pitchFamily="34" charset="0"/>
-                <a:ea typeface="Calibri" pitchFamily="34" charset="-122"/>
-                <a:cs typeface="Calibri" pitchFamily="34" charset="-120"/>
-              </a:rPr>
-              <a:t>A market reports all four basket foods in a month, or none of them, almost never a partial mix. A genuine, previously undocumented pattern in how WFP collects prices.</a:t>
-            </a:r>
-            <a:endParaRPr lang="en-US" sz="1000" dirty="0"/>
-          </a:p>
-        </p:txBody>
-      </p:sp>
-      <p:sp>
-        <p:nvSpPr>
-          <p:cNvPr id="20" name="Shape 18"/>
-          <p:cNvSpPr/>
-          <p:nvPr/>
-        </p:nvSpPr>
-        <p:spPr>
-          <a:xfrm>
-            <a:off x="566928" y="5943600"/>
-            <a:ext cx="11027664" cy="420624"/>
-          </a:xfrm>
-          <a:prstGeom prst="roundRect">
-            <a:avLst>
-              <a:gd name="adj" fmla="val 13043"/>
-            </a:avLst>
-          </a:prstGeom>
-          <a:solidFill>
-            <a:srgbClr val="2B2523"/>
-          </a:solidFill>
-          <a:ln/>
-          <a:effectLst>
-            <a:outerShdw sx="100000" sy="100000" kx="0" ky="0" algn="bl" rotWithShape="0" blurRad="76200" dist="381" dir="5400000">
-              <a:srgbClr val="000000">
-                <a:alpha val="8000"/>
-              </a:srgbClr>
-            </a:outerShdw>
-          </a:effectLst>
-        </p:spPr>
-      </p:sp>
-      <p:sp>
-        <p:nvSpPr>
-          <p:cNvPr id="21" name="Text 19"/>
-          <p:cNvSpPr/>
-          <p:nvPr/>
-        </p:nvSpPr>
-        <p:spPr>
-          <a:xfrm>
-            <a:off x="841248" y="6016752"/>
-            <a:ext cx="10479024" cy="292608"/>
-          </a:xfrm>
-          <a:prstGeom prst="rect">
-            <a:avLst/>
-          </a:prstGeom>
-          <a:noFill/>
-          <a:ln/>
-        </p:spPr>
-        <p:txBody>
-          <a:bodyPr wrap="square" lIns="0" tIns="0" rIns="0" bIns="0" rtlCol="0" anchor="ctr"/>
-          <a:lstStyle/>
-          <a:p>
-            <a:pPr indent="0" marL="0">
-              <a:buNone/>
-            </a:pPr>
-            <a:r>
-              <a:rPr lang="en-US" sz="1100" i="1" dirty="0">
-                <a:solidFill>
-                  <a:srgbClr val="E7E8D1"/>
-                </a:solidFill>
-                <a:latin typeface="Calibri" pitchFamily="34" charset="0"/>
-                <a:ea typeface="Calibri" pitchFamily="34" charset="-122"/>
-                <a:cs typeface="Calibri" pitchFamily="34" charset="-120"/>
-              </a:rPr>
-              <a:t>None require new data. All reuse the datasets already in the repository.</a:t>
-            </a:r>
-            <a:endParaRPr lang="en-US" sz="1100" dirty="0"/>
+              <a:t>Two more findings continue on the next slide.</a:t>
+            </a:r>
+            <a:endParaRPr lang="en-US" sz="900" dirty="0"/>
           </a:p>
         </p:txBody>
       </p:sp>
@@ -20434,7 +20628,7 @@
                 <a:ea typeface="Cambria" pitchFamily="34" charset="-122"/>
                 <a:cs typeface="Cambria" pitchFamily="34" charset="-120"/>
               </a:rPr>
-              <a:t>Next steps, part 2: new analysis still to run</a:t>
+              <a:t>Next steps, part 1: findings already in hand (continued)</a:t>
             </a:r>
             <a:endParaRPr lang="en-US" sz="2500" dirty="0"/>
           </a:p>
@@ -20473,7 +20667,7 @@
                 <a:ea typeface="Calibri" pitchFamily="34" charset="-122"/>
                 <a:cs typeface="Calibri" pitchFamily="34" charset="-120"/>
               </a:rPr>
-              <a:t>Identified this week, not yet built, each one sharpens one of the three sub-questions</a:t>
+              <a:t>Two more, both about the market trend and PEWI features specifically</a:t>
             </a:r>
             <a:endParaRPr lang="en-US" sz="1250" dirty="0"/>
           </a:p>
@@ -20488,11 +20682,11 @@
         <p:spPr>
           <a:xfrm>
             <a:off x="566928" y="1554480"/>
-            <a:ext cx="11027664" cy="1005840"/>
+            <a:ext cx="11027664" cy="1920240"/>
           </a:xfrm>
           <a:prstGeom prst="roundRect">
             <a:avLst>
-              <a:gd name="adj" fmla="val 5455"/>
+              <a:gd name="adj" fmla="val 2857"/>
             </a:avLst>
           </a:prstGeom>
           <a:solidFill>
@@ -20510,60 +20704,79 @@
       </p:sp>
       <p:sp>
         <p:nvSpPr>
-          <p:cNvPr id="5" name="Shape 3"/>
-          <p:cNvSpPr/>
-          <p:nvPr/>
-        </p:nvSpPr>
-        <p:spPr>
-          <a:xfrm>
-            <a:off x="749808" y="1719072"/>
-            <a:ext cx="384048" cy="384048"/>
-          </a:xfrm>
-          <a:prstGeom prst="ellipse">
-            <a:avLst/>
-          </a:prstGeom>
-          <a:solidFill>
-            <a:srgbClr val="B85042"/>
-          </a:solidFill>
-          <a:ln/>
-        </p:spPr>
-      </p:sp>
-      <p:sp>
-        <p:nvSpPr>
-          <p:cNvPr id="6" name="Text 4"/>
-          <p:cNvSpPr/>
-          <p:nvPr/>
-        </p:nvSpPr>
-        <p:spPr>
-          <a:xfrm>
-            <a:off x="749808" y="1719072"/>
-            <a:ext cx="384048" cy="384048"/>
-          </a:xfrm>
-          <a:prstGeom prst="rect">
-            <a:avLst/>
-          </a:prstGeom>
-          <a:noFill/>
-          <a:ln/>
-        </p:spPr>
-        <p:txBody>
-          <a:bodyPr wrap="square" lIns="0" tIns="0" rIns="0" bIns="0" rtlCol="0" anchor="ctr"/>
-          <a:lstStyle/>
-          <a:p>
-            <a:pPr algn="ctr" indent="0" marL="0">
-              <a:buNone/>
-            </a:pPr>
-            <a:r>
-              <a:rPr lang="en-US" sz="1200" b="1" dirty="0">
-                <a:solidFill>
-                  <a:srgbClr val="FFFFFF"/>
+          <p:cNvPr id="5" name="Text 3"/>
+          <p:cNvSpPr/>
+          <p:nvPr/>
+        </p:nvSpPr>
+        <p:spPr>
+          <a:xfrm>
+            <a:off x="841248" y="1700784"/>
+            <a:ext cx="10479024" cy="365760"/>
+          </a:xfrm>
+          <a:prstGeom prst="rect">
+            <a:avLst/>
+          </a:prstGeom>
+          <a:noFill/>
+          <a:ln/>
+        </p:spPr>
+        <p:txBody>
+          <a:bodyPr wrap="square" lIns="0" tIns="0" rIns="0" bIns="0" rtlCol="0" anchor="ctr"/>
+          <a:lstStyle/>
+          <a:p>
+            <a:pPr indent="0" marL="0">
+              <a:buNone/>
+            </a:pPr>
+            <a:r>
+              <a:rPr lang="en-US" sz="1400" b="1" dirty="0">
+                <a:solidFill>
+                  <a:srgbClr val="B85042"/>
                 </a:solidFill>
                 <a:latin typeface="Cambria" pitchFamily="34" charset="0"/>
                 <a:ea typeface="Cambria" pitchFamily="34" charset="-122"/>
                 <a:cs typeface="Cambria" pitchFamily="34" charset="-120"/>
               </a:rPr>
-              <a:t>1</a:t>
-            </a:r>
-            <a:endParaRPr lang="en-US" sz="1200" dirty="0"/>
+              <a:t>Trend features miss more than the prices they're built from</a:t>
+            </a:r>
+            <a:endParaRPr lang="en-US" sz="1400" dirty="0"/>
+          </a:p>
+        </p:txBody>
+      </p:sp>
+      <p:sp>
+        <p:nvSpPr>
+          <p:cNvPr id="6" name="Text 4"/>
+          <p:cNvSpPr/>
+          <p:nvPr/>
+        </p:nvSpPr>
+        <p:spPr>
+          <a:xfrm>
+            <a:off x="841248" y="2103120"/>
+            <a:ext cx="10479024" cy="365760"/>
+          </a:xfrm>
+          <a:prstGeom prst="rect">
+            <a:avLst/>
+          </a:prstGeom>
+          <a:noFill/>
+          <a:ln/>
+        </p:spPr>
+        <p:txBody>
+          <a:bodyPr wrap="square" lIns="0" tIns="0" rIns="0" bIns="0" rtlCol="0" anchor="ctr"/>
+          <a:lstStyle/>
+          <a:p>
+            <a:pPr indent="0" marL="0">
+              <a:buNone/>
+            </a:pPr>
+            <a:r>
+              <a:rPr lang="en-US" sz="1600" b="1" dirty="0">
+                <a:solidFill>
+                  <a:srgbClr val="2B2523"/>
+                </a:solidFill>
+                <a:latin typeface="Cambria" pitchFamily="34" charset="0"/>
+                <a:ea typeface="Cambria" pitchFamily="34" charset="-122"/>
+                <a:cs typeface="Cambria" pitchFamily="34" charset="-120"/>
+              </a:rPr>
+              <a:t>52.8%  -&gt;  56.8%</a:t>
+            </a:r>
+            <a:endParaRPr lang="en-US" sz="1600" dirty="0"/>
           </a:p>
         </p:txBody>
       </p:sp>
@@ -20575,8 +20788,8 @@
         </p:nvSpPr>
         <p:spPr>
           <a:xfrm>
-            <a:off x="1298448" y="1682496"/>
-            <a:ext cx="3703320" cy="749808"/>
+            <a:off x="841248" y="2523744"/>
+            <a:ext cx="10479024" cy="868680"/>
           </a:xfrm>
           <a:prstGeom prst="rect">
             <a:avLst/>
@@ -20595,49 +20808,7 @@
               <a:buNone/>
             </a:pPr>
             <a:r>
-              <a:rPr lang="en-US" sz="1250" b="1" dirty="0">
-                <a:solidFill>
-                  <a:srgbClr val="2B2523"/>
-                </a:solidFill>
-                <a:latin typeface="Cambria" pitchFamily="34" charset="0"/>
-                <a:ea typeface="Cambria" pitchFamily="34" charset="-122"/>
-                <a:cs typeface="Cambria" pitchFamily="34" charset="-120"/>
-              </a:rPr>
-              <a:t>One table, coverage by month</a:t>
-            </a:r>
-            <a:endParaRPr lang="en-US" sz="1250" dirty="0"/>
-          </a:p>
-        </p:txBody>
-      </p:sp>
-      <p:sp>
-        <p:nvSpPr>
-          <p:cNvPr id="8" name="Text 6"/>
-          <p:cNvSpPr/>
-          <p:nvPr/>
-        </p:nvSpPr>
-        <p:spPr>
-          <a:xfrm>
-            <a:off x="5349240" y="1645920"/>
-            <a:ext cx="5971032" cy="822960"/>
-          </a:xfrm>
-          <a:prstGeom prst="rect">
-            <a:avLst/>
-          </a:prstGeom>
-          <a:noFill/>
-          <a:ln/>
-        </p:spPr>
-        <p:txBody>
-          <a:bodyPr wrap="square" lIns="0" tIns="0" rIns="0" bIns="0" rtlCol="0" anchor="ctr"/>
-          <a:lstStyle/>
-          <a:p>
-            <a:pPr indent="0" marL="0">
-              <a:lnSpc>
-                <a:spcPts val="1300"/>
-              </a:lnSpc>
-              <a:buNone/>
-            </a:pPr>
-            <a:r>
-              <a:rPr lang="en-US" sz="1050" dirty="0">
+              <a:rPr lang="en-US" sz="1100" dirty="0">
                 <a:solidFill>
                   <a:srgbClr val="7A6E68"/>
                 </a:solidFill>
@@ -20645,26 +20816,26 @@
                 <a:ea typeface="Calibri" pitchFamily="34" charset="-122"/>
                 <a:cs typeface="Calibri" pitchFamily="34" charset="-120"/>
               </a:rPr>
-              <a:t>Pull the scattered month-by-month coverage numbers for every source into a single table, so the weakest months are visible at a glance.</a:t>
-            </a:r>
-            <a:endParaRPr lang="en-US" sz="1050" dirty="0"/>
-          </a:p>
-        </p:txBody>
-      </p:sp>
-      <p:sp>
-        <p:nvSpPr>
-          <p:cNvPr id="9" name="Shape 7"/>
-          <p:cNvSpPr/>
-          <p:nvPr/>
-        </p:nvSpPr>
-        <p:spPr>
-          <a:xfrm>
-            <a:off x="566928" y="2688336"/>
-            <a:ext cx="11027664" cy="1005840"/>
+              <a:t>A commodity's price is missing 52.8% of the time. Its month-over-month change (`{c}_trend_log`) is missing more, 56.8%, since a trend needs two consecutive months of price, not just one. This gap between the two figures has never been stated anywhere before.</a:t>
+            </a:r>
+            <a:endParaRPr lang="en-US" sz="1100" dirty="0"/>
+          </a:p>
+        </p:txBody>
+      </p:sp>
+      <p:sp>
+        <p:nvSpPr>
+          <p:cNvPr id="8" name="Shape 6"/>
+          <p:cNvSpPr/>
+          <p:nvPr/>
+        </p:nvSpPr>
+        <p:spPr>
+          <a:xfrm>
+            <a:off x="566928" y="3657600"/>
+            <a:ext cx="11027664" cy="1920240"/>
           </a:xfrm>
           <a:prstGeom prst="roundRect">
             <a:avLst>
-              <a:gd name="adj" fmla="val 5455"/>
+              <a:gd name="adj" fmla="val 2857"/>
             </a:avLst>
           </a:prstGeom>
           <a:solidFill>
@@ -20682,73 +20853,92 @@
       </p:sp>
       <p:sp>
         <p:nvSpPr>
-          <p:cNvPr id="10" name="Shape 8"/>
-          <p:cNvSpPr/>
-          <p:nvPr/>
-        </p:nvSpPr>
-        <p:spPr>
-          <a:xfrm>
-            <a:off x="749808" y="2852928"/>
-            <a:ext cx="384048" cy="384048"/>
-          </a:xfrm>
-          <a:prstGeom prst="ellipse">
-            <a:avLst/>
-          </a:prstGeom>
-          <a:solidFill>
-            <a:srgbClr val="B85042"/>
-          </a:solidFill>
-          <a:ln/>
-        </p:spPr>
-      </p:sp>
-      <p:sp>
-        <p:nvSpPr>
-          <p:cNvPr id="11" name="Text 9"/>
-          <p:cNvSpPr/>
-          <p:nvPr/>
-        </p:nvSpPr>
-        <p:spPr>
-          <a:xfrm>
-            <a:off x="749808" y="2852928"/>
-            <a:ext cx="384048" cy="384048"/>
-          </a:xfrm>
-          <a:prstGeom prst="rect">
-            <a:avLst/>
-          </a:prstGeom>
-          <a:noFill/>
-          <a:ln/>
-        </p:spPr>
-        <p:txBody>
-          <a:bodyPr wrap="square" lIns="0" tIns="0" rIns="0" bIns="0" rtlCol="0" anchor="ctr"/>
-          <a:lstStyle/>
-          <a:p>
-            <a:pPr algn="ctr" indent="0" marL="0">
-              <a:buNone/>
-            </a:pPr>
-            <a:r>
-              <a:rPr lang="en-US" sz="1200" b="1" dirty="0">
-                <a:solidFill>
-                  <a:srgbClr val="FFFFFF"/>
+          <p:cNvPr id="9" name="Text 7"/>
+          <p:cNvSpPr/>
+          <p:nvPr/>
+        </p:nvSpPr>
+        <p:spPr>
+          <a:xfrm>
+            <a:off x="841248" y="3803904"/>
+            <a:ext cx="10479024" cy="365760"/>
+          </a:xfrm>
+          <a:prstGeom prst="rect">
+            <a:avLst/>
+          </a:prstGeom>
+          <a:noFill/>
+          <a:ln/>
+        </p:spPr>
+        <p:txBody>
+          <a:bodyPr wrap="square" lIns="0" tIns="0" rIns="0" bIns="0" rtlCol="0" anchor="ctr"/>
+          <a:lstStyle/>
+          <a:p>
+            <a:pPr indent="0" marL="0">
+              <a:buNone/>
+            </a:pPr>
+            <a:r>
+              <a:rPr lang="en-US" sz="1400" b="1" dirty="0">
+                <a:solidFill>
+                  <a:srgbClr val="B85042"/>
                 </a:solidFill>
                 <a:latin typeface="Cambria" pitchFamily="34" charset="0"/>
                 <a:ea typeface="Cambria" pitchFamily="34" charset="-122"/>
                 <a:cs typeface="Cambria" pitchFamily="34" charset="-120"/>
               </a:rPr>
-              <a:t>2</a:t>
-            </a:r>
-            <a:endParaRPr lang="en-US" sz="1200" dirty="0"/>
-          </a:p>
-        </p:txBody>
-      </p:sp>
-      <p:sp>
-        <p:nvSpPr>
-          <p:cNvPr id="12" name="Text 10"/>
-          <p:cNvSpPr/>
-          <p:nvPr/>
-        </p:nvSpPr>
-        <p:spPr>
-          <a:xfrm>
-            <a:off x="1298448" y="2816352"/>
-            <a:ext cx="3703320" cy="749808"/>
+              <a:t>"Whole basket or nothing" reporting</a:t>
+            </a:r>
+            <a:endParaRPr lang="en-US" sz="1400" dirty="0"/>
+          </a:p>
+        </p:txBody>
+      </p:sp>
+      <p:sp>
+        <p:nvSpPr>
+          <p:cNvPr id="10" name="Text 8"/>
+          <p:cNvSpPr/>
+          <p:nvPr/>
+        </p:nvSpPr>
+        <p:spPr>
+          <a:xfrm>
+            <a:off x="841248" y="4206240"/>
+            <a:ext cx="10479024" cy="365760"/>
+          </a:xfrm>
+          <a:prstGeom prst="rect">
+            <a:avLst/>
+          </a:prstGeom>
+          <a:noFill/>
+          <a:ln/>
+        </p:spPr>
+        <p:txBody>
+          <a:bodyPr wrap="square" lIns="0" tIns="0" rIns="0" bIns="0" rtlCol="0" anchor="ctr"/>
+          <a:lstStyle/>
+          <a:p>
+            <a:pPr indent="0" marL="0">
+              <a:buNone/>
+            </a:pPr>
+            <a:r>
+              <a:rPr lang="en-US" sz="1600" b="1" dirty="0">
+                <a:solidFill>
+                  <a:srgbClr val="2B2523"/>
+                </a:solidFill>
+                <a:latin typeface="Cambria" pitchFamily="34" charset="0"/>
+                <a:ea typeface="Cambria" pitchFamily="34" charset="-122"/>
+                <a:cs typeface="Cambria" pitchFamily="34" charset="-120"/>
+              </a:rPr>
+              <a:t>99.4% all-or-nothing</a:t>
+            </a:r>
+            <a:endParaRPr lang="en-US" sz="1600" dirty="0"/>
+          </a:p>
+        </p:txBody>
+      </p:sp>
+      <p:sp>
+        <p:nvSpPr>
+          <p:cNvPr id="11" name="Text 9"/>
+          <p:cNvSpPr/>
+          <p:nvPr/>
+        </p:nvSpPr>
+        <p:spPr>
+          <a:xfrm>
+            <a:off x="841248" y="4626864"/>
+            <a:ext cx="10479024" cy="868680"/>
           </a:xfrm>
           <a:prstGeom prst="rect">
             <a:avLst/>
@@ -20767,49 +20957,7 @@
               <a:buNone/>
             </a:pPr>
             <a:r>
-              <a:rPr lang="en-US" sz="1250" b="1" dirty="0">
-                <a:solidFill>
-                  <a:srgbClr val="2B2523"/>
-                </a:solidFill>
-                <a:latin typeface="Cambria" pitchFamily="34" charset="0"/>
-                <a:ea typeface="Cambria" pitchFamily="34" charset="-122"/>
-                <a:cs typeface="Cambria" pitchFamily="34" charset="-120"/>
-              </a:rPr>
-              <a:t>Is market placement itself systematic?</a:t>
-            </a:r>
-            <a:endParaRPr lang="en-US" sz="1250" dirty="0"/>
-          </a:p>
-        </p:txBody>
-      </p:sp>
-      <p:sp>
-        <p:nvSpPr>
-          <p:cNvPr id="13" name="Text 11"/>
-          <p:cNvSpPr/>
-          <p:nvPr/>
-        </p:nvSpPr>
-        <p:spPr>
-          <a:xfrm>
-            <a:off x="5349240" y="2779776"/>
-            <a:ext cx="5971032" cy="822960"/>
-          </a:xfrm>
-          <a:prstGeom prst="rect">
-            <a:avLst/>
-          </a:prstGeom>
-          <a:noFill/>
-          <a:ln/>
-        </p:spPr>
-        <p:txBody>
-          <a:bodyPr wrap="square" lIns="0" tIns="0" rIns="0" bIns="0" rtlCol="0" anchor="ctr"/>
-          <a:lstStyle/>
-          <a:p>
-            <a:pPr indent="0" marL="0">
-              <a:lnSpc>
-                <a:spcPts val="1300"/>
-              </a:lnSpc>
-              <a:buNone/>
-            </a:pPr>
-            <a:r>
-              <a:rPr lang="en-US" sz="1050" dirty="0">
+              <a:rPr lang="en-US" sz="1100" dirty="0">
                 <a:solidFill>
                   <a:srgbClr val="7A6E68"/>
                 </a:solidFill>
@@ -20817,30 +20965,30 @@
                 <a:ea typeface="Calibri" pitchFamily="34" charset="-122"/>
                 <a:cs typeface="Calibri" pitchFamily="34" charset="-120"/>
               </a:rPr>
-              <a:t>Market presence has only been checked against conflict. Check it against region and district size too, the same treatment reporting coverage already got.</a:t>
-            </a:r>
-            <a:endParaRPr lang="en-US" sz="1050" dirty="0"/>
-          </a:p>
-        </p:txBody>
-      </p:sp>
-      <p:sp>
-        <p:nvSpPr>
-          <p:cNvPr id="14" name="Shape 12"/>
-          <p:cNvSpPr/>
-          <p:nvPr/>
-        </p:nvSpPr>
-        <p:spPr>
-          <a:xfrm>
-            <a:off x="566928" y="3822192"/>
-            <a:ext cx="11027664" cy="1005840"/>
+              <a:t>Checked, row by row, whether a market ever reports some of the four basket foods in a month but not others. It almost never happens: for both price and its trend, a market-month has all four commodities or none. PEWI follows the same pattern 99.4% of the time, with exactly 3 exceptions, all in Banadir. A genuine, previously undocumented pattern in how WFP collects prices.</a:t>
+            </a:r>
+            <a:endParaRPr lang="en-US" sz="1100" dirty="0"/>
+          </a:p>
+        </p:txBody>
+      </p:sp>
+      <p:sp>
+        <p:nvSpPr>
+          <p:cNvPr id="12" name="Shape 10"/>
+          <p:cNvSpPr/>
+          <p:nvPr/>
+        </p:nvSpPr>
+        <p:spPr>
+          <a:xfrm>
+            <a:off x="566928" y="5632704"/>
+            <a:ext cx="11027664" cy="457200"/>
           </a:xfrm>
           <a:prstGeom prst="roundRect">
             <a:avLst>
-              <a:gd name="adj" fmla="val 5455"/>
+              <a:gd name="adj" fmla="val 12000"/>
             </a:avLst>
           </a:prstGeom>
           <a:solidFill>
-            <a:srgbClr val="F7F5F1"/>
+            <a:srgbClr val="2B2523"/>
           </a:solidFill>
           <a:ln/>
           <a:effectLst>
@@ -20854,134 +21002,140 @@
       </p:sp>
       <p:sp>
         <p:nvSpPr>
-          <p:cNvPr id="15" name="Shape 13"/>
-          <p:cNvSpPr/>
-          <p:nvPr/>
-        </p:nvSpPr>
-        <p:spPr>
-          <a:xfrm>
-            <a:off x="749808" y="3986784"/>
-            <a:ext cx="384048" cy="384048"/>
-          </a:xfrm>
-          <a:prstGeom prst="ellipse">
-            <a:avLst/>
-          </a:prstGeom>
-          <a:solidFill>
-            <a:srgbClr val="B85042"/>
-          </a:solidFill>
-          <a:ln/>
-        </p:spPr>
-      </p:sp>
-      <p:sp>
-        <p:nvSpPr>
-          <p:cNvPr id="16" name="Text 14"/>
-          <p:cNvSpPr/>
-          <p:nvPr/>
-        </p:nvSpPr>
-        <p:spPr>
-          <a:xfrm>
-            <a:off x="749808" y="3986784"/>
-            <a:ext cx="384048" cy="384048"/>
-          </a:xfrm>
-          <a:prstGeom prst="rect">
-            <a:avLst/>
-          </a:prstGeom>
-          <a:noFill/>
-          <a:ln/>
-        </p:spPr>
-        <p:txBody>
-          <a:bodyPr wrap="square" lIns="0" tIns="0" rIns="0" bIns="0" rtlCol="0" anchor="ctr"/>
-          <a:lstStyle/>
-          <a:p>
-            <a:pPr algn="ctr" indent="0" marL="0">
-              <a:buNone/>
-            </a:pPr>
-            <a:r>
-              <a:rPr lang="en-US" sz="1200" b="1" dirty="0">
-                <a:solidFill>
-                  <a:srgbClr val="FFFFFF"/>
+          <p:cNvPr id="13" name="Text 11"/>
+          <p:cNvSpPr/>
+          <p:nvPr/>
+        </p:nvSpPr>
+        <p:spPr>
+          <a:xfrm>
+            <a:off x="841248" y="5724144"/>
+            <a:ext cx="10479024" cy="310896"/>
+          </a:xfrm>
+          <a:prstGeom prst="rect">
+            <a:avLst/>
+          </a:prstGeom>
+          <a:noFill/>
+          <a:ln/>
+        </p:spPr>
+        <p:txBody>
+          <a:bodyPr wrap="square" lIns="0" tIns="0" rIns="0" bIns="0" rtlCol="0" anchor="ctr"/>
+          <a:lstStyle/>
+          <a:p>
+            <a:pPr indent="0" marL="0">
+              <a:buNone/>
+            </a:pPr>
+            <a:r>
+              <a:rPr lang="en-US" sz="1100" i="1" dirty="0">
+                <a:solidFill>
+                  <a:srgbClr val="E7E8D1"/>
+                </a:solidFill>
+                <a:latin typeface="Calibri" pitchFamily="34" charset="0"/>
+                <a:ea typeface="Calibri" pitchFamily="34" charset="-122"/>
+                <a:cs typeface="Calibri" pitchFamily="34" charset="-120"/>
+              </a:rPr>
+              <a:t>All five findings on these two slides reuse datasets already in the repository. None require new data.</a:t>
+            </a:r>
+            <a:endParaRPr lang="en-US" sz="1100" dirty="0"/>
+          </a:p>
+        </p:txBody>
+      </p:sp>
+    </p:spTree>
+  </p:cSld>
+  <p:clrMapOvr>
+    <a:masterClrMapping/>
+  </p:clrMapOvr>
+</p:sld>
+</file>
+
+<file path=ppt/slides/slide31.xml><?xml version="1.0" encoding="utf-8"?>
+<p:sld xmlns:a="http://schemas.openxmlformats.org/drawingml/2006/main" xmlns:r="http://schemas.openxmlformats.org/officeDocument/2006/relationships" xmlns:p="http://schemas.openxmlformats.org/presentationml/2006/main">
+  <p:cSld name="Slide 31">
+    <p:bg>
+      <p:bgPr>
+        <a:solidFill>
+          <a:srgbClr val="FFFFFF"/>
+        </a:solidFill>
+      </p:bgPr>
+    </p:bg>
+    <p:spTree>
+      <p:nvGrpSpPr>
+        <p:cNvPr id="1" name=""/>
+        <p:cNvGrpSpPr/>
+        <p:nvPr/>
+      </p:nvGrpSpPr>
+      <p:grpSpPr>
+        <a:xfrm>
+          <a:off x="0" y="0"/>
+          <a:ext cx="0" cy="0"/>
+          <a:chOff x="0" y="0"/>
+          <a:chExt cx="0" cy="0"/>
+        </a:xfrm>
+      </p:grpSpPr>
+      <p:sp>
+        <p:nvSpPr>
+          <p:cNvPr id="2" name="Text 0"/>
+          <p:cNvSpPr/>
+          <p:nvPr/>
+        </p:nvSpPr>
+        <p:spPr>
+          <a:xfrm>
+            <a:off x="566928" y="457200"/>
+            <a:ext cx="11027664" cy="548640"/>
+          </a:xfrm>
+          <a:prstGeom prst="rect">
+            <a:avLst/>
+          </a:prstGeom>
+          <a:noFill/>
+          <a:ln/>
+        </p:spPr>
+        <p:txBody>
+          <a:bodyPr wrap="square" lIns="0" tIns="0" rIns="0" bIns="0" rtlCol="0" anchor="ctr"/>
+          <a:lstStyle/>
+          <a:p>
+            <a:pPr indent="0" marL="0">
+              <a:buNone/>
+            </a:pPr>
+            <a:r>
+              <a:rPr lang="en-US" sz="2500" b="1" dirty="0">
+                <a:solidFill>
+                  <a:srgbClr val="2B2523"/>
                 </a:solidFill>
                 <a:latin typeface="Cambria" pitchFamily="34" charset="0"/>
                 <a:ea typeface="Cambria" pitchFamily="34" charset="-122"/>
                 <a:cs typeface="Cambria" pitchFamily="34" charset="-120"/>
               </a:rPr>
-              <a:t>3</a:t>
-            </a:r>
-            <a:endParaRPr lang="en-US" sz="1200" dirty="0"/>
-          </a:p>
-        </p:txBody>
-      </p:sp>
-      <p:sp>
-        <p:nvSpPr>
-          <p:cNvPr id="17" name="Text 15"/>
-          <p:cNvSpPr/>
-          <p:nvPr/>
-        </p:nvSpPr>
-        <p:spPr>
-          <a:xfrm>
-            <a:off x="1298448" y="3950208"/>
-            <a:ext cx="3703320" cy="749808"/>
-          </a:xfrm>
-          <a:prstGeom prst="rect">
-            <a:avLst/>
-          </a:prstGeom>
-          <a:noFill/>
-          <a:ln/>
-        </p:spPr>
-        <p:txBody>
-          <a:bodyPr wrap="square" lIns="0" tIns="0" rIns="0" bIns="0" rtlCol="0" anchor="ctr"/>
-          <a:lstStyle/>
-          <a:p>
-            <a:pPr indent="0" marL="0">
-              <a:lnSpc>
-                <a:spcPts val="1500"/>
-              </a:lnSpc>
-              <a:buNone/>
-            </a:pPr>
-            <a:r>
-              <a:rPr lang="en-US" sz="1250" b="1" dirty="0">
-                <a:solidFill>
-                  <a:srgbClr val="2B2523"/>
-                </a:solidFill>
-                <a:latin typeface="Cambria" pitchFamily="34" charset="0"/>
-                <a:ea typeface="Cambria" pitchFamily="34" charset="-122"/>
-                <a:cs typeface="Cambria" pitchFamily="34" charset="-120"/>
-              </a:rPr>
-              <a:t>Do the sources agree on where the crisis is?</a:t>
-            </a:r>
-            <a:endParaRPr lang="en-US" sz="1250" dirty="0"/>
-          </a:p>
-        </p:txBody>
-      </p:sp>
-      <p:sp>
-        <p:nvSpPr>
-          <p:cNvPr id="18" name="Text 16"/>
-          <p:cNvSpPr/>
-          <p:nvPr/>
-        </p:nvSpPr>
-        <p:spPr>
-          <a:xfrm>
-            <a:off x="5349240" y="3913632"/>
-            <a:ext cx="5971032" cy="822960"/>
-          </a:xfrm>
-          <a:prstGeom prst="rect">
-            <a:avLst/>
-          </a:prstGeom>
-          <a:noFill/>
-          <a:ln/>
-        </p:spPr>
-        <p:txBody>
-          <a:bodyPr wrap="square" lIns="0" tIns="0" rIns="0" bIns="0" rtlCol="0" anchor="ctr"/>
-          <a:lstStyle/>
-          <a:p>
-            <a:pPr indent="0" marL="0">
-              <a:lnSpc>
-                <a:spcPts val="1300"/>
-              </a:lnSpc>
-              <a:buNone/>
-            </a:pPr>
-            <a:r>
-              <a:rPr lang="en-US" sz="1050" dirty="0">
+              <a:t>Next steps, part 2: new analysis still to run (1 of 4)</a:t>
+            </a:r>
+            <a:endParaRPr lang="en-US" sz="2500" dirty="0"/>
+          </a:p>
+        </p:txBody>
+      </p:sp>
+      <p:sp>
+        <p:nvSpPr>
+          <p:cNvPr id="3" name="Text 1"/>
+          <p:cNvSpPr/>
+          <p:nvPr/>
+        </p:nvSpPr>
+        <p:spPr>
+          <a:xfrm>
+            <a:off x="566928" y="987552"/>
+            <a:ext cx="11027664" cy="329184"/>
+          </a:xfrm>
+          <a:prstGeom prst="rect">
+            <a:avLst/>
+          </a:prstGeom>
+          <a:noFill/>
+          <a:ln/>
+        </p:spPr>
+        <p:txBody>
+          <a:bodyPr wrap="square" lIns="0" tIns="0" rIns="0" bIns="0" rtlCol="0" anchor="ctr"/>
+          <a:lstStyle/>
+          <a:p>
+            <a:pPr indent="0" marL="0">
+              <a:buNone/>
+            </a:pPr>
+            <a:r>
+              <a:rPr lang="en-US" sz="1250" i="1" dirty="0">
                 <a:solidFill>
                   <a:srgbClr val="7A6E68"/>
                 </a:solidFill>
@@ -20989,30 +21143,30 @@
                 <a:ea typeface="Calibri" pitchFamily="34" charset="-122"/>
                 <a:cs typeface="Calibri" pitchFamily="34" charset="-120"/>
               </a:rPr>
-              <a:t>So far we've only checked whether sources cover the same places. Check whether conflict-severe districts are also the ones with stressed markets, or whether the two point elsewhere.</a:t>
-            </a:r>
-            <a:endParaRPr lang="en-US" sz="1050" dirty="0"/>
-          </a:p>
-        </p:txBody>
-      </p:sp>
-      <p:sp>
-        <p:nvSpPr>
-          <p:cNvPr id="19" name="Shape 17"/>
-          <p:cNvSpPr/>
-          <p:nvPr/>
-        </p:nvSpPr>
-        <p:spPr>
-          <a:xfrm>
-            <a:off x="566928" y="4956048"/>
-            <a:ext cx="11027664" cy="1005840"/>
+              <a:t>One table, coverage by month</a:t>
+            </a:r>
+            <a:endParaRPr lang="en-US" sz="1250" dirty="0"/>
+          </a:p>
+        </p:txBody>
+      </p:sp>
+      <p:sp>
+        <p:nvSpPr>
+          <p:cNvPr id="4" name="Shape 2"/>
+          <p:cNvSpPr/>
+          <p:nvPr/>
+        </p:nvSpPr>
+        <p:spPr>
+          <a:xfrm>
+            <a:off x="566928" y="1517904"/>
+            <a:ext cx="11027664" cy="1188720"/>
           </a:xfrm>
           <a:prstGeom prst="roundRect">
             <a:avLst>
-              <a:gd name="adj" fmla="val 5455"/>
+              <a:gd name="adj" fmla="val 4615"/>
             </a:avLst>
           </a:prstGeom>
           <a:solidFill>
-            <a:srgbClr val="F7F5F1"/>
+            <a:srgbClr val="2B2523"/>
           </a:solidFill>
           <a:ln/>
           <a:effectLst>
@@ -21026,73 +21180,53 @@
       </p:sp>
       <p:sp>
         <p:nvSpPr>
-          <p:cNvPr id="20" name="Shape 18"/>
-          <p:cNvSpPr/>
-          <p:nvPr/>
-        </p:nvSpPr>
-        <p:spPr>
-          <a:xfrm>
-            <a:off x="749808" y="5120640"/>
-            <a:ext cx="384048" cy="384048"/>
-          </a:xfrm>
-          <a:prstGeom prst="ellipse">
-            <a:avLst/>
-          </a:prstGeom>
-          <a:solidFill>
-            <a:srgbClr val="B85042"/>
-          </a:solidFill>
-          <a:ln/>
-        </p:spPr>
-      </p:sp>
-      <p:sp>
-        <p:nvSpPr>
-          <p:cNvPr id="21" name="Text 19"/>
-          <p:cNvSpPr/>
-          <p:nvPr/>
-        </p:nvSpPr>
-        <p:spPr>
-          <a:xfrm>
-            <a:off x="749808" y="5120640"/>
-            <a:ext cx="384048" cy="384048"/>
-          </a:xfrm>
-          <a:prstGeom prst="rect">
-            <a:avLst/>
-          </a:prstGeom>
-          <a:noFill/>
-          <a:ln/>
-        </p:spPr>
-        <p:txBody>
-          <a:bodyPr wrap="square" lIns="0" tIns="0" rIns="0" bIns="0" rtlCol="0" anchor="ctr"/>
-          <a:lstStyle/>
-          <a:p>
-            <a:pPr algn="ctr" indent="0" marL="0">
-              <a:buNone/>
-            </a:pPr>
-            <a:r>
-              <a:rPr lang="en-US" sz="1200" b="1" dirty="0">
-                <a:solidFill>
-                  <a:srgbClr val="FFFFFF"/>
+          <p:cNvPr id="5" name="Text 3"/>
+          <p:cNvSpPr/>
+          <p:nvPr/>
+        </p:nvSpPr>
+        <p:spPr>
+          <a:xfrm>
+            <a:off x="841248" y="1645920"/>
+            <a:ext cx="10479024" cy="274320"/>
+          </a:xfrm>
+          <a:prstGeom prst="rect">
+            <a:avLst/>
+          </a:prstGeom>
+          <a:noFill/>
+          <a:ln/>
+        </p:spPr>
+        <p:txBody>
+          <a:bodyPr wrap="square" lIns="0" tIns="0" rIns="0" bIns="0" rtlCol="0" anchor="ctr"/>
+          <a:lstStyle/>
+          <a:p>
+            <a:pPr indent="0" marL="0">
+              <a:buNone/>
+            </a:pPr>
+            <a:r>
+              <a:rPr lang="en-US" sz="1300" b="1" dirty="0">
+                <a:solidFill>
+                  <a:srgbClr val="A7BEAE"/>
                 </a:solidFill>
                 <a:latin typeface="Cambria" pitchFamily="34" charset="0"/>
                 <a:ea typeface="Cambria" pitchFamily="34" charset="-122"/>
                 <a:cs typeface="Cambria" pitchFamily="34" charset="-120"/>
               </a:rPr>
-              <a:t>4</a:t>
-            </a:r>
-            <a:endParaRPr lang="en-US" sz="1200" dirty="0"/>
-          </a:p>
-        </p:txBody>
-      </p:sp>
-      <p:sp>
-        <p:nvSpPr>
-          <p:cNvPr id="22" name="Text 20"/>
-          <p:cNvSpPr/>
-          <p:nvPr/>
-        </p:nvSpPr>
-        <p:spPr>
-          <a:xfrm>
-            <a:off x="1298448" y="5084064"/>
-            <a:ext cx="3703320" cy="749808"/>
+              <a:t>Why</a:t>
+            </a:r>
+            <a:endParaRPr lang="en-US" sz="1300" dirty="0"/>
+          </a:p>
+        </p:txBody>
+      </p:sp>
+      <p:sp>
+        <p:nvSpPr>
+          <p:cNvPr id="6" name="Text 4"/>
+          <p:cNvSpPr/>
+          <p:nvPr/>
+        </p:nvSpPr>
+        <p:spPr>
+          <a:xfrm>
+            <a:off x="841248" y="1920240"/>
+            <a:ext cx="10479024" cy="731520"/>
           </a:xfrm>
           <a:prstGeom prst="rect">
             <a:avLst/>
@@ -21111,15 +21245,350 @@
               <a:buNone/>
             </a:pPr>
             <a:r>
-              <a:rPr lang="en-US" sz="1250" b="1" dirty="0">
-                <a:solidFill>
-                  <a:srgbClr val="2B2523"/>
+              <a:rPr lang="en-US" sz="1150" dirty="0">
+                <a:solidFill>
+                  <a:srgbClr val="E7E8D1"/>
+                </a:solidFill>
+                <a:latin typeface="Calibri" pitchFamily="34" charset="0"/>
+                <a:ea typeface="Calibri" pitchFamily="34" charset="-122"/>
+                <a:cs typeface="Calibri" pitchFamily="34" charset="-120"/>
+              </a:rPr>
+              <a:t>The numbers on which months are well or poorly covered already exist, but scattered: the WFP audit has a month-by-month table, reporting's 34-54 swing is mentioned in prose, market's flat 34-35 is mentioned separately. Nothing currently puts all four sources side by side, by month.</a:t>
+            </a:r>
+            <a:endParaRPr lang="en-US" sz="1150" dirty="0"/>
+          </a:p>
+        </p:txBody>
+      </p:sp>
+      <p:sp>
+        <p:nvSpPr>
+          <p:cNvPr id="7" name="Shape 5"/>
+          <p:cNvSpPr/>
+          <p:nvPr/>
+        </p:nvSpPr>
+        <p:spPr>
+          <a:xfrm>
+            <a:off x="566928" y="2889504"/>
+            <a:ext cx="11027664" cy="2377440"/>
+          </a:xfrm>
+          <a:prstGeom prst="roundRect">
+            <a:avLst>
+              <a:gd name="adj" fmla="val 2308"/>
+            </a:avLst>
+          </a:prstGeom>
+          <a:solidFill>
+            <a:srgbClr val="F7F5F1"/>
+          </a:solidFill>
+          <a:ln/>
+          <a:effectLst>
+            <a:outerShdw sx="100000" sy="100000" kx="0" ky="0" algn="bl" rotWithShape="0" blurRad="76200" dist="381" dir="5400000">
+              <a:srgbClr val="000000">
+                <a:alpha val="8000"/>
+              </a:srgbClr>
+            </a:outerShdw>
+          </a:effectLst>
+        </p:spPr>
+      </p:sp>
+      <p:sp>
+        <p:nvSpPr>
+          <p:cNvPr id="8" name="Text 6"/>
+          <p:cNvSpPr/>
+          <p:nvPr/>
+        </p:nvSpPr>
+        <p:spPr>
+          <a:xfrm>
+            <a:off x="841248" y="3017520"/>
+            <a:ext cx="10479024" cy="274320"/>
+          </a:xfrm>
+          <a:prstGeom prst="rect">
+            <a:avLst/>
+          </a:prstGeom>
+          <a:noFill/>
+          <a:ln/>
+        </p:spPr>
+        <p:txBody>
+          <a:bodyPr wrap="square" lIns="0" tIns="0" rIns="0" bIns="0" rtlCol="0" anchor="ctr"/>
+          <a:lstStyle/>
+          <a:p>
+            <a:pPr indent="0" marL="0">
+              <a:buNone/>
+            </a:pPr>
+            <a:r>
+              <a:rPr lang="en-US" sz="1300" b="1" dirty="0">
+                <a:solidFill>
+                  <a:srgbClr val="B85042"/>
                 </a:solidFill>
                 <a:latin typeface="Cambria" pitchFamily="34" charset="0"/>
                 <a:ea typeface="Cambria" pitchFamily="34" charset="-122"/>
                 <a:cs typeface="Cambria" pitchFamily="34" charset="-120"/>
               </a:rPr>
-              <a:t>A note on how fine-grained each source is</a:t>
+              <a:t>What we will actually do</a:t>
+            </a:r>
+            <a:endParaRPr lang="en-US" sz="1300" dirty="0"/>
+          </a:p>
+        </p:txBody>
+      </p:sp>
+      <p:sp>
+        <p:nvSpPr>
+          <p:cNvPr id="9" name="Text 7"/>
+          <p:cNvSpPr/>
+          <p:nvPr/>
+        </p:nvSpPr>
+        <p:spPr>
+          <a:xfrm>
+            <a:off x="841248" y="3310128"/>
+            <a:ext cx="10479024" cy="1828800"/>
+          </a:xfrm>
+          <a:prstGeom prst="rect">
+            <a:avLst/>
+          </a:prstGeom>
+          <a:noFill/>
+          <a:ln/>
+        </p:spPr>
+        <p:txBody>
+          <a:bodyPr wrap="square" lIns="0" tIns="0" rIns="0" bIns="0" rtlCol="0" anchor="ctr"/>
+          <a:lstStyle/>
+          <a:p>
+            <a:pPr marL="342900" indent="-342900">
+              <a:lnSpc>
+                <a:spcPts val="1500"/>
+              </a:lnSpc>
+              <a:spcAft>
+                <a:spcPts val="900"/>
+              </a:spcAft>
+              <a:buSzPct val="100000"/>
+              <a:buChar char="•"/>
+            </a:pPr>
+            <a:r>
+              <a:rPr lang="en-US" sz="1150" dirty="0">
+                <a:solidFill>
+                  <a:srgbClr val="7A6E68"/>
+                </a:solidFill>
+                <a:latin typeface="Calibri" pitchFamily="34" charset="0"/>
+                <a:ea typeface="Calibri" pitchFamily="34" charset="-122"/>
+                <a:cs typeface="Calibri" pitchFamily="34" charset="-120"/>
+              </a:rPr>
+              <a:t>Take the panel's existing per-source coverage flags (already used elsewhere: was conflict/climate/market/reporting observed for this district-month)</a:t>
+            </a:r>
+            <a:endParaRPr lang="en-US" sz="1150" dirty="0"/>
+          </a:p>
+          <a:p>
+            <a:pPr marL="342900" indent="-342900">
+              <a:lnSpc>
+                <a:spcPts val="1500"/>
+              </a:lnSpc>
+              <a:spcAft>
+                <a:spcPts val="900"/>
+              </a:spcAft>
+              <a:buSzPct val="100000"/>
+              <a:buChar char="•"/>
+            </a:pPr>
+            <a:r>
+              <a:rPr lang="en-US" sz="1150" dirty="0">
+                <a:solidFill>
+                  <a:srgbClr val="7A6E68"/>
+                </a:solidFill>
+                <a:latin typeface="Calibri" pitchFamily="34" charset="0"/>
+                <a:ea typeface="Calibri" pitchFamily="34" charset="-122"/>
+                <a:cs typeface="Calibri" pitchFamily="34" charset="-120"/>
+              </a:rPr>
+              <a:t>Group the 888 rows by month (time_id) instead of by district</a:t>
+            </a:r>
+            <a:endParaRPr lang="en-US" sz="1150" dirty="0"/>
+          </a:p>
+          <a:p>
+            <a:pPr marL="342900" indent="-342900">
+              <a:lnSpc>
+                <a:spcPts val="1500"/>
+              </a:lnSpc>
+              <a:spcAft>
+                <a:spcPts val="900"/>
+              </a:spcAft>
+              <a:buSzPct val="100000"/>
+              <a:buChar char="•"/>
+            </a:pPr>
+            <a:r>
+              <a:rPr lang="en-US" sz="1150" dirty="0">
+                <a:solidFill>
+                  <a:srgbClr val="7A6E68"/>
+                </a:solidFill>
+                <a:latin typeface="Calibri" pitchFamily="34" charset="0"/>
+                <a:ea typeface="Calibri" pitchFamily="34" charset="-122"/>
+                <a:cs typeface="Calibri" pitchFamily="34" charset="-120"/>
+              </a:rPr>
+              <a:t>For each of the 12 months, calculate what percentage of the 74 districts each source covered that month</a:t>
+            </a:r>
+            <a:endParaRPr lang="en-US" sz="1150" dirty="0"/>
+          </a:p>
+          <a:p>
+            <a:pPr marL="342900" indent="-342900">
+              <a:lnSpc>
+                <a:spcPts val="1500"/>
+              </a:lnSpc>
+              <a:spcAft>
+                <a:spcPts val="900"/>
+              </a:spcAft>
+              <a:buSzPct val="100000"/>
+              <a:buChar char="•"/>
+            </a:pPr>
+            <a:r>
+              <a:rPr lang="en-US" sz="1150" dirty="0">
+                <a:solidFill>
+                  <a:srgbClr val="7A6E68"/>
+                </a:solidFill>
+                <a:latin typeface="Calibri" pitchFamily="34" charset="0"/>
+                <a:ea typeface="Calibri" pitchFamily="34" charset="-122"/>
+                <a:cs typeface="Calibri" pitchFamily="34" charset="-120"/>
+              </a:rPr>
+              <a:t>Assemble the result into one 12-row table, one column per source, so the weakest months for each source are visible side by side</a:t>
+            </a:r>
+            <a:endParaRPr lang="en-US" sz="1150" dirty="0"/>
+          </a:p>
+        </p:txBody>
+      </p:sp>
+      <p:sp>
+        <p:nvSpPr>
+          <p:cNvPr id="10" name="Text 8"/>
+          <p:cNvSpPr/>
+          <p:nvPr/>
+        </p:nvSpPr>
+        <p:spPr>
+          <a:xfrm>
+            <a:off x="566928" y="6144768"/>
+            <a:ext cx="11027664" cy="237744"/>
+          </a:xfrm>
+          <a:prstGeom prst="rect">
+            <a:avLst/>
+          </a:prstGeom>
+          <a:noFill/>
+          <a:ln/>
+        </p:spPr>
+        <p:txBody>
+          <a:bodyPr wrap="square" lIns="0" tIns="0" rIns="0" bIns="0" rtlCol="0" anchor="ctr"/>
+          <a:lstStyle/>
+          <a:p>
+            <a:pPr indent="0" marL="0">
+              <a:buNone/>
+            </a:pPr>
+            <a:r>
+              <a:rPr lang="en-US" sz="900" i="1" dirty="0">
+                <a:solidFill>
+                  <a:srgbClr val="7A6E68"/>
+                </a:solidFill>
+                <a:latin typeface="Calibri" pitchFamily="34" charset="0"/>
+                <a:ea typeface="Calibri" pitchFamily="34" charset="-122"/>
+                <a:cs typeface="Calibri" pitchFamily="34" charset="-120"/>
+              </a:rPr>
+              <a:t>No new computation beyond a groupby on columns that already exist in the panel. The smallest of the four items here.</a:t>
+            </a:r>
+            <a:endParaRPr lang="en-US" sz="900" dirty="0"/>
+          </a:p>
+        </p:txBody>
+      </p:sp>
+    </p:spTree>
+  </p:cSld>
+  <p:clrMapOvr>
+    <a:masterClrMapping/>
+  </p:clrMapOvr>
+</p:sld>
+</file>
+
+<file path=ppt/slides/slide32.xml><?xml version="1.0" encoding="utf-8"?>
+<p:sld xmlns:a="http://schemas.openxmlformats.org/drawingml/2006/main" xmlns:r="http://schemas.openxmlformats.org/officeDocument/2006/relationships" xmlns:p="http://schemas.openxmlformats.org/presentationml/2006/main">
+  <p:cSld name="Slide 32">
+    <p:bg>
+      <p:bgPr>
+        <a:solidFill>
+          <a:srgbClr val="FFFFFF"/>
+        </a:solidFill>
+      </p:bgPr>
+    </p:bg>
+    <p:spTree>
+      <p:nvGrpSpPr>
+        <p:cNvPr id="1" name=""/>
+        <p:cNvGrpSpPr/>
+        <p:nvPr/>
+      </p:nvGrpSpPr>
+      <p:grpSpPr>
+        <a:xfrm>
+          <a:off x="0" y="0"/>
+          <a:ext cx="0" cy="0"/>
+          <a:chOff x="0" y="0"/>
+          <a:chExt cx="0" cy="0"/>
+        </a:xfrm>
+      </p:grpSpPr>
+      <p:sp>
+        <p:nvSpPr>
+          <p:cNvPr id="2" name="Text 0"/>
+          <p:cNvSpPr/>
+          <p:nvPr/>
+        </p:nvSpPr>
+        <p:spPr>
+          <a:xfrm>
+            <a:off x="566928" y="457200"/>
+            <a:ext cx="11027664" cy="548640"/>
+          </a:xfrm>
+          <a:prstGeom prst="rect">
+            <a:avLst/>
+          </a:prstGeom>
+          <a:noFill/>
+          <a:ln/>
+        </p:spPr>
+        <p:txBody>
+          <a:bodyPr wrap="square" lIns="0" tIns="0" rIns="0" bIns="0" rtlCol="0" anchor="ctr"/>
+          <a:lstStyle/>
+          <a:p>
+            <a:pPr indent="0" marL="0">
+              <a:buNone/>
+            </a:pPr>
+            <a:r>
+              <a:rPr lang="en-US" sz="2500" b="1" dirty="0">
+                <a:solidFill>
+                  <a:srgbClr val="2B2523"/>
+                </a:solidFill>
+                <a:latin typeface="Cambria" pitchFamily="34" charset="0"/>
+                <a:ea typeface="Cambria" pitchFamily="34" charset="-122"/>
+                <a:cs typeface="Cambria" pitchFamily="34" charset="-120"/>
+              </a:rPr>
+              <a:t>Next steps, part 2: new analysis still to run (2 of 4)</a:t>
+            </a:r>
+            <a:endParaRPr lang="en-US" sz="2500" dirty="0"/>
+          </a:p>
+        </p:txBody>
+      </p:sp>
+      <p:sp>
+        <p:nvSpPr>
+          <p:cNvPr id="3" name="Text 1"/>
+          <p:cNvSpPr/>
+          <p:nvPr/>
+        </p:nvSpPr>
+        <p:spPr>
+          <a:xfrm>
+            <a:off x="566928" y="987552"/>
+            <a:ext cx="11027664" cy="329184"/>
+          </a:xfrm>
+          <a:prstGeom prst="rect">
+            <a:avLst/>
+          </a:prstGeom>
+          <a:noFill/>
+          <a:ln/>
+        </p:spPr>
+        <p:txBody>
+          <a:bodyPr wrap="square" lIns="0" tIns="0" rIns="0" bIns="0" rtlCol="0" anchor="ctr"/>
+          <a:lstStyle/>
+          <a:p>
+            <a:pPr indent="0" marL="0">
+              <a:buNone/>
+            </a:pPr>
+            <a:r>
+              <a:rPr lang="en-US" sz="1250" i="1" dirty="0">
+                <a:solidFill>
+                  <a:srgbClr val="7A6E68"/>
+                </a:solidFill>
+                <a:latin typeface="Calibri" pitchFamily="34" charset="0"/>
+                <a:ea typeface="Calibri" pitchFamily="34" charset="-122"/>
+                <a:cs typeface="Calibri" pitchFamily="34" charset="-120"/>
+              </a:rPr>
+              <a:t>Is market placement itself systematic?</a:t>
             </a:r>
             <a:endParaRPr lang="en-US" sz="1250" dirty="0"/>
           </a:p>
@@ -21127,30 +21596,657 @@
       </p:sp>
       <p:sp>
         <p:nvSpPr>
-          <p:cNvPr id="23" name="Text 21"/>
-          <p:cNvSpPr/>
-          <p:nvPr/>
-        </p:nvSpPr>
-        <p:spPr>
-          <a:xfrm>
-            <a:off x="5349240" y="5047488"/>
-            <a:ext cx="5971032" cy="822960"/>
-          </a:xfrm>
-          <a:prstGeom prst="rect">
-            <a:avLst/>
-          </a:prstGeom>
-          <a:noFill/>
-          <a:ln/>
-        </p:spPr>
-        <p:txBody>
-          <a:bodyPr wrap="square" lIns="0" tIns="0" rIns="0" bIns="0" rtlCol="0" anchor="ctr"/>
-          <a:lstStyle/>
-          <a:p>
-            <a:pPr indent="0" marL="0">
+          <p:cNvPr id="4" name="Shape 2"/>
+          <p:cNvSpPr/>
+          <p:nvPr/>
+        </p:nvSpPr>
+        <p:spPr>
+          <a:xfrm>
+            <a:off x="566928" y="1517904"/>
+            <a:ext cx="11027664" cy="1188720"/>
+          </a:xfrm>
+          <a:prstGeom prst="roundRect">
+            <a:avLst>
+              <a:gd name="adj" fmla="val 4615"/>
+            </a:avLst>
+          </a:prstGeom>
+          <a:solidFill>
+            <a:srgbClr val="2B2523"/>
+          </a:solidFill>
+          <a:ln/>
+          <a:effectLst>
+            <a:outerShdw sx="100000" sy="100000" kx="0" ky="0" algn="bl" rotWithShape="0" blurRad="76200" dist="381" dir="5400000">
+              <a:srgbClr val="000000">
+                <a:alpha val="8000"/>
+              </a:srgbClr>
+            </a:outerShdw>
+          </a:effectLst>
+        </p:spPr>
+      </p:sp>
+      <p:sp>
+        <p:nvSpPr>
+          <p:cNvPr id="5" name="Text 3"/>
+          <p:cNvSpPr/>
+          <p:nvPr/>
+        </p:nvSpPr>
+        <p:spPr>
+          <a:xfrm>
+            <a:off x="841248" y="1645920"/>
+            <a:ext cx="10479024" cy="274320"/>
+          </a:xfrm>
+          <a:prstGeom prst="rect">
+            <a:avLst/>
+          </a:prstGeom>
+          <a:noFill/>
+          <a:ln/>
+        </p:spPr>
+        <p:txBody>
+          <a:bodyPr wrap="square" lIns="0" tIns="0" rIns="0" bIns="0" rtlCol="0" anchor="ctr"/>
+          <a:lstStyle/>
+          <a:p>
+            <a:pPr indent="0" marL="0">
+              <a:buNone/>
+            </a:pPr>
+            <a:r>
+              <a:rPr lang="en-US" sz="1300" b="1" dirty="0">
+                <a:solidFill>
+                  <a:srgbClr val="A7BEAE"/>
+                </a:solidFill>
+                <a:latin typeface="Cambria" pitchFamily="34" charset="0"/>
+                <a:ea typeface="Cambria" pitchFamily="34" charset="-122"/>
+                <a:cs typeface="Cambria" pitchFamily="34" charset="-120"/>
+              </a:rPr>
+              <a:t>Why</a:t>
+            </a:r>
+            <a:endParaRPr lang="en-US" sz="1300" dirty="0"/>
+          </a:p>
+        </p:txBody>
+      </p:sp>
+      <p:sp>
+        <p:nvSpPr>
+          <p:cNvPr id="6" name="Text 4"/>
+          <p:cNvSpPr/>
+          <p:nvPr/>
+        </p:nvSpPr>
+        <p:spPr>
+          <a:xfrm>
+            <a:off x="841248" y="1920240"/>
+            <a:ext cx="10479024" cy="731520"/>
+          </a:xfrm>
+          <a:prstGeom prst="rect">
+            <a:avLst/>
+          </a:prstGeom>
+          <a:noFill/>
+          <a:ln/>
+        </p:spPr>
+        <p:txBody>
+          <a:bodyPr wrap="square" lIns="0" tIns="0" rIns="0" bIns="0" rtlCol="0" anchor="ctr"/>
+          <a:lstStyle/>
+          <a:p>
+            <a:pPr indent="0" marL="0">
+              <a:lnSpc>
+                <a:spcPts val="1500"/>
+              </a:lnSpc>
+              <a:buNone/>
+            </a:pPr>
+            <a:r>
+              <a:rPr lang="en-US" sz="1150" dirty="0">
+                <a:solidFill>
+                  <a:srgbClr val="E7E8D1"/>
+                </a:solidFill>
+                <a:latin typeface="Calibri" pitchFamily="34" charset="0"/>
+                <a:ea typeface="Calibri" pitchFamily="34" charset="-122"/>
+                <a:cs typeface="Calibri" pitchFamily="34" charset="-120"/>
+              </a:rPr>
+              <a:t>Sub-question 2 asks whether gaps are systematic. That has only been tested properly for reporting coverage (conflict, market status and region, in the logistic regression). Market coverage itself, which districts have a monitored market at all, has only ever been checked against conflict, and found not significant.</a:t>
+            </a:r>
+            <a:endParaRPr lang="en-US" sz="1150" dirty="0"/>
+          </a:p>
+        </p:txBody>
+      </p:sp>
+      <p:sp>
+        <p:nvSpPr>
+          <p:cNvPr id="7" name="Shape 5"/>
+          <p:cNvSpPr/>
+          <p:nvPr/>
+        </p:nvSpPr>
+        <p:spPr>
+          <a:xfrm>
+            <a:off x="566928" y="2889504"/>
+            <a:ext cx="11027664" cy="2377440"/>
+          </a:xfrm>
+          <a:prstGeom prst="roundRect">
+            <a:avLst>
+              <a:gd name="adj" fmla="val 2308"/>
+            </a:avLst>
+          </a:prstGeom>
+          <a:solidFill>
+            <a:srgbClr val="F7F5F1"/>
+          </a:solidFill>
+          <a:ln/>
+          <a:effectLst>
+            <a:outerShdw sx="100000" sy="100000" kx="0" ky="0" algn="bl" rotWithShape="0" blurRad="76200" dist="381" dir="5400000">
+              <a:srgbClr val="000000">
+                <a:alpha val="8000"/>
+              </a:srgbClr>
+            </a:outerShdw>
+          </a:effectLst>
+        </p:spPr>
+      </p:sp>
+      <p:sp>
+        <p:nvSpPr>
+          <p:cNvPr id="8" name="Text 6"/>
+          <p:cNvSpPr/>
+          <p:nvPr/>
+        </p:nvSpPr>
+        <p:spPr>
+          <a:xfrm>
+            <a:off x="841248" y="3017520"/>
+            <a:ext cx="10479024" cy="274320"/>
+          </a:xfrm>
+          <a:prstGeom prst="rect">
+            <a:avLst/>
+          </a:prstGeom>
+          <a:noFill/>
+          <a:ln/>
+        </p:spPr>
+        <p:txBody>
+          <a:bodyPr wrap="square" lIns="0" tIns="0" rIns="0" bIns="0" rtlCol="0" anchor="ctr"/>
+          <a:lstStyle/>
+          <a:p>
+            <a:pPr indent="0" marL="0">
+              <a:buNone/>
+            </a:pPr>
+            <a:r>
+              <a:rPr lang="en-US" sz="1300" b="1" dirty="0">
+                <a:solidFill>
+                  <a:srgbClr val="B85042"/>
+                </a:solidFill>
+                <a:latin typeface="Cambria" pitchFamily="34" charset="0"/>
+                <a:ea typeface="Cambria" pitchFamily="34" charset="-122"/>
+                <a:cs typeface="Cambria" pitchFamily="34" charset="-120"/>
+              </a:rPr>
+              <a:t>What we will actually do</a:t>
+            </a:r>
+            <a:endParaRPr lang="en-US" sz="1300" dirty="0"/>
+          </a:p>
+        </p:txBody>
+      </p:sp>
+      <p:sp>
+        <p:nvSpPr>
+          <p:cNvPr id="9" name="Text 7"/>
+          <p:cNvSpPr/>
+          <p:nvPr/>
+        </p:nvSpPr>
+        <p:spPr>
+          <a:xfrm>
+            <a:off x="841248" y="3310128"/>
+            <a:ext cx="10479024" cy="1828800"/>
+          </a:xfrm>
+          <a:prstGeom prst="rect">
+            <a:avLst/>
+          </a:prstGeom>
+          <a:noFill/>
+          <a:ln/>
+        </p:spPr>
+        <p:txBody>
+          <a:bodyPr wrap="square" lIns="0" tIns="0" rIns="0" bIns="0" rtlCol="0" anchor="ctr"/>
+          <a:lstStyle/>
+          <a:p>
+            <a:pPr marL="342900" indent="-342900">
+              <a:lnSpc>
+                <a:spcPts val="1500"/>
+              </a:lnSpc>
+              <a:spcAft>
+                <a:spcPts val="900"/>
+              </a:spcAft>
+              <a:buSzPct val="100000"/>
+              <a:buChar char="•"/>
+            </a:pPr>
+            <a:r>
+              <a:rPr lang="en-US" sz="1150" dirty="0">
+                <a:solidFill>
+                  <a:srgbClr val="7A6E68"/>
+                </a:solidFill>
+                <a:latin typeface="Calibri" pitchFamily="34" charset="0"/>
+                <a:ea typeface="Calibri" pitchFamily="34" charset="-122"/>
+                <a:cs typeface="Calibri" pitchFamily="34" charset="-120"/>
+              </a:rPr>
+              <a:t>has_market_coverage does not change month to month, so this is tested at the district level (n=74), the same correction already applied to every other district-fixed variable</a:t>
+            </a:r>
+            <a:endParaRPr lang="en-US" sz="1150" dirty="0"/>
+          </a:p>
+          <a:p>
+            <a:pPr marL="342900" indent="-342900">
+              <a:lnSpc>
+                <a:spcPts val="1500"/>
+              </a:lnSpc>
+              <a:spcAft>
+                <a:spcPts val="900"/>
+              </a:spcAft>
+              <a:buSzPct val="100000"/>
+              <a:buChar char="•"/>
+            </a:pPr>
+            <a:r>
+              <a:rPr lang="en-US" sz="1150" dirty="0">
+                <a:solidFill>
+                  <a:srgbClr val="7A6E68"/>
+                </a:solidFill>
+                <a:latin typeface="Calibri" pitchFamily="34" charset="0"/>
+                <a:ea typeface="Calibri" pitchFamily="34" charset="-122"/>
+                <a:cs typeface="Calibri" pitchFamily="34" charset="-120"/>
+              </a:rPr>
+              <a:t>Check whether market presence relates to region (admin1): a simple breakdown of the percentage of districts with a market, by region</a:t>
+            </a:r>
+            <a:endParaRPr lang="en-US" sz="1150" dirty="0"/>
+          </a:p>
+          <a:p>
+            <a:pPr marL="342900" indent="-342900">
+              <a:lnSpc>
+                <a:spcPts val="1500"/>
+              </a:lnSpc>
+              <a:spcAft>
+                <a:spcPts val="900"/>
+              </a:spcAft>
+              <a:buSzPct val="100000"/>
+              <a:buChar char="•"/>
+            </a:pPr>
+            <a:r>
+              <a:rPr lang="en-US" sz="1150" dirty="0">
+                <a:solidFill>
+                  <a:srgbClr val="7A6E68"/>
+                </a:solidFill>
+                <a:latin typeface="Calibri" pitchFamily="34" charset="0"/>
+                <a:ea typeface="Calibri" pitchFamily="34" charset="-122"/>
+                <a:cs typeface="Calibri" pitchFamily="34" charset="-120"/>
+              </a:rPr>
+              <a:t>Check whether it relates to district size (area_km2): the same kind of correlation already run informally for reporting coverage, but never reported cleanly on its own</a:t>
+            </a:r>
+            <a:endParaRPr lang="en-US" sz="1150" dirty="0"/>
+          </a:p>
+          <a:p>
+            <a:pPr marL="342900" indent="-342900">
+              <a:lnSpc>
+                <a:spcPts val="1500"/>
+              </a:lnSpc>
+              <a:spcAft>
+                <a:spcPts val="900"/>
+              </a:spcAft>
+              <a:buSzPct val="100000"/>
+              <a:buChar char="•"/>
+            </a:pPr>
+            <a:r>
+              <a:rPr lang="en-US" sz="1150" dirty="0">
+                <a:solidFill>
+                  <a:srgbClr val="7A6E68"/>
+                </a:solidFill>
+                <a:latin typeface="Calibri" pitchFamily="34" charset="0"/>
+                <a:ea typeface="Calibri" pitchFamily="34" charset="-122"/>
+                <a:cs typeface="Calibri" pitchFamily="34" charset="-120"/>
+              </a:rPr>
+              <a:t>Report the result plainly either way: systematic (tied to region or size) or close to random placement</a:t>
+            </a:r>
+            <a:endParaRPr lang="en-US" sz="1150" dirty="0"/>
+          </a:p>
+        </p:txBody>
+      </p:sp>
+      <p:sp>
+        <p:nvSpPr>
+          <p:cNvPr id="10" name="Text 8"/>
+          <p:cNvSpPr/>
+          <p:nvPr/>
+        </p:nvSpPr>
+        <p:spPr>
+          <a:xfrm>
+            <a:off x="566928" y="6144768"/>
+            <a:ext cx="11027664" cy="237744"/>
+          </a:xfrm>
+          <a:prstGeom prst="rect">
+            <a:avLst/>
+          </a:prstGeom>
+          <a:noFill/>
+          <a:ln/>
+        </p:spPr>
+        <p:txBody>
+          <a:bodyPr wrap="square" lIns="0" tIns="0" rIns="0" bIns="0" rtlCol="0" anchor="ctr"/>
+          <a:lstStyle/>
+          <a:p>
+            <a:pPr indent="0" marL="0">
+              <a:buNone/>
+            </a:pPr>
+            <a:r>
+              <a:rPr lang="en-US" sz="900" i="1" dirty="0">
+                <a:solidFill>
+                  <a:srgbClr val="7A6E68"/>
+                </a:solidFill>
+                <a:latin typeface="Calibri" pitchFamily="34" charset="0"/>
+                <a:ea typeface="Calibri" pitchFamily="34" charset="-122"/>
+                <a:cs typeface="Calibri" pitchFamily="34" charset="-120"/>
+              </a:rPr>
+              <a:t>District-level only, so this does not run into the repeated-district-months problem from earlier.</a:t>
+            </a:r>
+            <a:endParaRPr lang="en-US" sz="900" dirty="0"/>
+          </a:p>
+        </p:txBody>
+      </p:sp>
+    </p:spTree>
+  </p:cSld>
+  <p:clrMapOvr>
+    <a:masterClrMapping/>
+  </p:clrMapOvr>
+</p:sld>
+</file>
+
+<file path=ppt/slides/slide33.xml><?xml version="1.0" encoding="utf-8"?>
+<p:sld xmlns:a="http://schemas.openxmlformats.org/drawingml/2006/main" xmlns:r="http://schemas.openxmlformats.org/officeDocument/2006/relationships" xmlns:p="http://schemas.openxmlformats.org/presentationml/2006/main">
+  <p:cSld name="Slide 33">
+    <p:bg>
+      <p:bgPr>
+        <a:solidFill>
+          <a:srgbClr val="FFFFFF"/>
+        </a:solidFill>
+      </p:bgPr>
+    </p:bg>
+    <p:spTree>
+      <p:nvGrpSpPr>
+        <p:cNvPr id="1" name=""/>
+        <p:cNvGrpSpPr/>
+        <p:nvPr/>
+      </p:nvGrpSpPr>
+      <p:grpSpPr>
+        <a:xfrm>
+          <a:off x="0" y="0"/>
+          <a:ext cx="0" cy="0"/>
+          <a:chOff x="0" y="0"/>
+          <a:chExt cx="0" cy="0"/>
+        </a:xfrm>
+      </p:grpSpPr>
+      <p:sp>
+        <p:nvSpPr>
+          <p:cNvPr id="2" name="Text 0"/>
+          <p:cNvSpPr/>
+          <p:nvPr/>
+        </p:nvSpPr>
+        <p:spPr>
+          <a:xfrm>
+            <a:off x="566928" y="457200"/>
+            <a:ext cx="11027664" cy="548640"/>
+          </a:xfrm>
+          <a:prstGeom prst="rect">
+            <a:avLst/>
+          </a:prstGeom>
+          <a:noFill/>
+          <a:ln/>
+        </p:spPr>
+        <p:txBody>
+          <a:bodyPr wrap="square" lIns="0" tIns="0" rIns="0" bIns="0" rtlCol="0" anchor="ctr"/>
+          <a:lstStyle/>
+          <a:p>
+            <a:pPr indent="0" marL="0">
+              <a:buNone/>
+            </a:pPr>
+            <a:r>
+              <a:rPr lang="en-US" sz="2500" b="1" dirty="0">
+                <a:solidFill>
+                  <a:srgbClr val="2B2523"/>
+                </a:solidFill>
+                <a:latin typeface="Cambria" pitchFamily="34" charset="0"/>
+                <a:ea typeface="Cambria" pitchFamily="34" charset="-122"/>
+                <a:cs typeface="Cambria" pitchFamily="34" charset="-120"/>
+              </a:rPr>
+              <a:t>Next steps, part 2: new analysis still to run (3 of 4)</a:t>
+            </a:r>
+            <a:endParaRPr lang="en-US" sz="2500" dirty="0"/>
+          </a:p>
+        </p:txBody>
+      </p:sp>
+      <p:sp>
+        <p:nvSpPr>
+          <p:cNvPr id="3" name="Text 1"/>
+          <p:cNvSpPr/>
+          <p:nvPr/>
+        </p:nvSpPr>
+        <p:spPr>
+          <a:xfrm>
+            <a:off x="566928" y="987552"/>
+            <a:ext cx="11027664" cy="329184"/>
+          </a:xfrm>
+          <a:prstGeom prst="rect">
+            <a:avLst/>
+          </a:prstGeom>
+          <a:noFill/>
+          <a:ln/>
+        </p:spPr>
+        <p:txBody>
+          <a:bodyPr wrap="square" lIns="0" tIns="0" rIns="0" bIns="0" rtlCol="0" anchor="ctr"/>
+          <a:lstStyle/>
+          <a:p>
+            <a:pPr indent="0" marL="0">
+              <a:buNone/>
+            </a:pPr>
+            <a:r>
+              <a:rPr lang="en-US" sz="1250" i="1" dirty="0">
+                <a:solidFill>
+                  <a:srgbClr val="7A6E68"/>
+                </a:solidFill>
+                <a:latin typeface="Calibri" pitchFamily="34" charset="0"/>
+                <a:ea typeface="Calibri" pitchFamily="34" charset="-122"/>
+                <a:cs typeface="Calibri" pitchFamily="34" charset="-120"/>
+              </a:rPr>
+              <a:t>Do the sources agree on where the crisis actually is?</a:t>
+            </a:r>
+            <a:endParaRPr lang="en-US" sz="1250" dirty="0"/>
+          </a:p>
+        </p:txBody>
+      </p:sp>
+      <p:sp>
+        <p:nvSpPr>
+          <p:cNvPr id="4" name="Shape 2"/>
+          <p:cNvSpPr/>
+          <p:nvPr/>
+        </p:nvSpPr>
+        <p:spPr>
+          <a:xfrm>
+            <a:off x="566928" y="1517904"/>
+            <a:ext cx="11027664" cy="1097280"/>
+          </a:xfrm>
+          <a:prstGeom prst="roundRect">
+            <a:avLst>
+              <a:gd name="adj" fmla="val 5000"/>
+            </a:avLst>
+          </a:prstGeom>
+          <a:solidFill>
+            <a:srgbClr val="2B2523"/>
+          </a:solidFill>
+          <a:ln/>
+          <a:effectLst>
+            <a:outerShdw sx="100000" sy="100000" kx="0" ky="0" algn="bl" rotWithShape="0" blurRad="76200" dist="381" dir="5400000">
+              <a:srgbClr val="000000">
+                <a:alpha val="8000"/>
+              </a:srgbClr>
+            </a:outerShdw>
+          </a:effectLst>
+        </p:spPr>
+      </p:sp>
+      <p:sp>
+        <p:nvSpPr>
+          <p:cNvPr id="5" name="Text 3"/>
+          <p:cNvSpPr/>
+          <p:nvPr/>
+        </p:nvSpPr>
+        <p:spPr>
+          <a:xfrm>
+            <a:off x="841248" y="1627632"/>
+            <a:ext cx="10479024" cy="274320"/>
+          </a:xfrm>
+          <a:prstGeom prst="rect">
+            <a:avLst/>
+          </a:prstGeom>
+          <a:noFill/>
+          <a:ln/>
+        </p:spPr>
+        <p:txBody>
+          <a:bodyPr wrap="square" lIns="0" tIns="0" rIns="0" bIns="0" rtlCol="0" anchor="ctr"/>
+          <a:lstStyle/>
+          <a:p>
+            <a:pPr indent="0" marL="0">
+              <a:buNone/>
+            </a:pPr>
+            <a:r>
+              <a:rPr lang="en-US" sz="1300" b="1" dirty="0">
+                <a:solidFill>
+                  <a:srgbClr val="A7BEAE"/>
+                </a:solidFill>
+                <a:latin typeface="Cambria" pitchFamily="34" charset="0"/>
+                <a:ea typeface="Cambria" pitchFamily="34" charset="-122"/>
+                <a:cs typeface="Cambria" pitchFamily="34" charset="-120"/>
+              </a:rPr>
+              <a:t>Why</a:t>
+            </a:r>
+            <a:endParaRPr lang="en-US" sz="1300" dirty="0"/>
+          </a:p>
+        </p:txBody>
+      </p:sp>
+      <p:sp>
+        <p:nvSpPr>
+          <p:cNvPr id="6" name="Text 4"/>
+          <p:cNvSpPr/>
+          <p:nvPr/>
+        </p:nvSpPr>
+        <p:spPr>
+          <a:xfrm>
+            <a:off x="841248" y="1883664"/>
+            <a:ext cx="10479024" cy="685800"/>
+          </a:xfrm>
+          <a:prstGeom prst="rect">
+            <a:avLst/>
+          </a:prstGeom>
+          <a:noFill/>
+          <a:ln/>
+        </p:spPr>
+        <p:txBody>
+          <a:bodyPr wrap="square" lIns="0" tIns="0" rIns="0" bIns="0" rtlCol="0" anchor="ctr"/>
+          <a:lstStyle/>
+          <a:p>
+            <a:pPr indent="0" marL="0">
+              <a:lnSpc>
+                <a:spcPts val="1400"/>
+              </a:lnSpc>
+              <a:buNone/>
+            </a:pPr>
+            <a:r>
+              <a:rPr lang="en-US" sz="1100" dirty="0">
+                <a:solidFill>
+                  <a:srgbClr val="E7E8D1"/>
+                </a:solidFill>
+                <a:latin typeface="Calibri" pitchFamily="34" charset="0"/>
+                <a:ea typeface="Calibri" pitchFamily="34" charset="-122"/>
+                <a:cs typeface="Calibri" pitchFamily="34" charset="-120"/>
+              </a:rPr>
+              <a:t>Source complementarity so far only asks whether sources cover the same places. It has never asked whether, when two sources are both watching, they actually agree on what they see: does a district with severe conflict also show up as under market stress, or do the two mechanisms point at different places?</a:t>
+            </a:r>
+            <a:endParaRPr lang="en-US" sz="1100" dirty="0"/>
+          </a:p>
+        </p:txBody>
+      </p:sp>
+      <p:sp>
+        <p:nvSpPr>
+          <p:cNvPr id="7" name="Shape 5"/>
+          <p:cNvSpPr/>
+          <p:nvPr/>
+        </p:nvSpPr>
+        <p:spPr>
+          <a:xfrm>
+            <a:off x="566928" y="2724912"/>
+            <a:ext cx="11027664" cy="1828800"/>
+          </a:xfrm>
+          <a:prstGeom prst="roundRect">
+            <a:avLst>
+              <a:gd name="adj" fmla="val 3000"/>
+            </a:avLst>
+          </a:prstGeom>
+          <a:solidFill>
+            <a:srgbClr val="F7F5F1"/>
+          </a:solidFill>
+          <a:ln/>
+          <a:effectLst>
+            <a:outerShdw sx="100000" sy="100000" kx="0" ky="0" algn="bl" rotWithShape="0" blurRad="76200" dist="381" dir="5400000">
+              <a:srgbClr val="000000">
+                <a:alpha val="8000"/>
+              </a:srgbClr>
+            </a:outerShdw>
+          </a:effectLst>
+        </p:spPr>
+      </p:sp>
+      <p:sp>
+        <p:nvSpPr>
+          <p:cNvPr id="8" name="Text 6"/>
+          <p:cNvSpPr/>
+          <p:nvPr/>
+        </p:nvSpPr>
+        <p:spPr>
+          <a:xfrm>
+            <a:off x="841248" y="2834640"/>
+            <a:ext cx="10479024" cy="274320"/>
+          </a:xfrm>
+          <a:prstGeom prst="rect">
+            <a:avLst/>
+          </a:prstGeom>
+          <a:noFill/>
+          <a:ln/>
+        </p:spPr>
+        <p:txBody>
+          <a:bodyPr wrap="square" lIns="0" tIns="0" rIns="0" bIns="0" rtlCol="0" anchor="ctr"/>
+          <a:lstStyle/>
+          <a:p>
+            <a:pPr indent="0" marL="0">
+              <a:buNone/>
+            </a:pPr>
+            <a:r>
+              <a:rPr lang="en-US" sz="1300" b="1" dirty="0">
+                <a:solidFill>
+                  <a:srgbClr val="B85042"/>
+                </a:solidFill>
+                <a:latin typeface="Cambria" pitchFamily="34" charset="0"/>
+                <a:ea typeface="Cambria" pitchFamily="34" charset="-122"/>
+                <a:cs typeface="Cambria" pitchFamily="34" charset="-120"/>
+              </a:rPr>
+              <a:t>What we will actually do</a:t>
+            </a:r>
+            <a:endParaRPr lang="en-US" sz="1300" dirty="0"/>
+          </a:p>
+        </p:txBody>
+      </p:sp>
+      <p:sp>
+        <p:nvSpPr>
+          <p:cNvPr id="9" name="Text 7"/>
+          <p:cNvSpPr/>
+          <p:nvPr/>
+        </p:nvSpPr>
+        <p:spPr>
+          <a:xfrm>
+            <a:off x="841248" y="3127248"/>
+            <a:ext cx="10479024" cy="1371600"/>
+          </a:xfrm>
+          <a:prstGeom prst="rect">
+            <a:avLst/>
+          </a:prstGeom>
+          <a:noFill/>
+          <a:ln/>
+        </p:spPr>
+        <p:txBody>
+          <a:bodyPr wrap="square" lIns="0" tIns="0" rIns="0" bIns="0" rtlCol="0" anchor="ctr"/>
+          <a:lstStyle/>
+          <a:p>
+            <a:pPr marL="342900" indent="-342900">
               <a:lnSpc>
                 <a:spcPts val="1300"/>
               </a:lnSpc>
-              <a:buNone/>
+              <a:spcAft>
+                <a:spcPts val="700"/>
+              </a:spcAft>
+              <a:buSzPct val="100000"/>
+              <a:buChar char="•"/>
             </a:pPr>
             <a:r>
               <a:rPr lang="en-US" sz="1050" dirty="0">
@@ -21161,9 +22257,678 @@
                 <a:ea typeface="Calibri" pitchFamily="34" charset="-122"/>
                 <a:cs typeface="Calibri" pitchFamily="34" charset="-120"/>
               </a:rPr>
-              <a:t>The research question asks about granularity by name. Document each source's native resolution, from exact GPS points down to a whole document, before it collapses to one number per district.</a:t>
+              <a:t>Restrict to the 383 district-months that actually have market data, so a "not stressed" reading isn't confused with "no data"</a:t>
             </a:r>
             <a:endParaRPr lang="en-US" sz="1050" dirty="0"/>
+          </a:p>
+          <a:p>
+            <a:pPr marL="342900" indent="-342900">
+              <a:lnSpc>
+                <a:spcPts val="1300"/>
+              </a:lnSpc>
+              <a:spcAft>
+                <a:spcPts val="700"/>
+              </a:spcAft>
+              <a:buSzPct val="100000"/>
+              <a:buChar char="•"/>
+            </a:pPr>
+            <a:r>
+              <a:rPr lang="en-US" sz="1050" dirty="0">
+                <a:solidFill>
+                  <a:srgbClr val="7A6E68"/>
+                </a:solidFill>
+                <a:latin typeface="Calibri" pitchFamily="34" charset="0"/>
+                <a:ea typeface="Calibri" pitchFamily="34" charset="-122"/>
+                <a:cs typeface="Calibri" pitchFamily="34" charset="-120"/>
+              </a:rPr>
+              <a:t>Flag conflict-severe district-months using the same worst-10% definition used throughout the conflict-vs-climate work</a:t>
+            </a:r>
+            <a:endParaRPr lang="en-US" sz="1050" dirty="0"/>
+          </a:p>
+          <a:p>
+            <a:pPr marL="342900" indent="-342900">
+              <a:lnSpc>
+                <a:spcPts val="1300"/>
+              </a:lnSpc>
+              <a:spcAft>
+                <a:spcPts val="700"/>
+              </a:spcAft>
+              <a:buSzPct val="100000"/>
+              <a:buChar char="•"/>
+            </a:pPr>
+            <a:r>
+              <a:rPr lang="en-US" sz="1050" dirty="0">
+                <a:solidFill>
+                  <a:srgbClr val="7A6E68"/>
+                </a:solidFill>
+                <a:latin typeface="Calibri" pitchFamily="34" charset="0"/>
+                <a:ea typeface="Calibri" pitchFamily="34" charset="-122"/>
+                <a:cs typeface="Calibri" pitchFamily="34" charset="-120"/>
+              </a:rPr>
+              <a:t>Flag market-stressed district-months as market_stress_count &gt; 0 (WFP's Alert-or-worse phase)</a:t>
+            </a:r>
+            <a:endParaRPr lang="en-US" sz="1050" dirty="0"/>
+          </a:p>
+          <a:p>
+            <a:pPr marL="342900" indent="-342900">
+              <a:lnSpc>
+                <a:spcPts val="1300"/>
+              </a:lnSpc>
+              <a:spcAft>
+                <a:spcPts val="700"/>
+              </a:spcAft>
+              <a:buSzPct val="100000"/>
+              <a:buChar char="•"/>
+            </a:pPr>
+            <a:r>
+              <a:rPr lang="en-US" sz="1050" dirty="0">
+                <a:solidFill>
+                  <a:srgbClr val="7A6E68"/>
+                </a:solidFill>
+                <a:latin typeface="Calibri" pitchFamily="34" charset="0"/>
+                <a:ea typeface="Calibri" pitchFamily="34" charset="-122"/>
+                <a:cs typeface="Calibri" pitchFamily="34" charset="-120"/>
+              </a:rPr>
+              <a:t>Cross-tabulate the two flags and test the association, then apply the same district-level and cluster-bootstrap checks used for the conflict-vs-climate result, since a handful of repeat districts could otherwise distort it</a:t>
+            </a:r>
+            <a:endParaRPr lang="en-US" sz="1050" dirty="0"/>
+          </a:p>
+        </p:txBody>
+      </p:sp>
+      <p:sp>
+        <p:nvSpPr>
+          <p:cNvPr id="10" name="Shape 8"/>
+          <p:cNvSpPr/>
+          <p:nvPr/>
+        </p:nvSpPr>
+        <p:spPr>
+          <a:xfrm>
+            <a:off x="566928" y="4663440"/>
+            <a:ext cx="11027664" cy="1417320"/>
+          </a:xfrm>
+          <a:prstGeom prst="roundRect">
+            <a:avLst>
+              <a:gd name="adj" fmla="val 3871"/>
+            </a:avLst>
+          </a:prstGeom>
+          <a:solidFill>
+            <a:srgbClr val="E7E8D1"/>
+          </a:solidFill>
+          <a:ln/>
+          <a:effectLst>
+            <a:outerShdw sx="100000" sy="100000" kx="0" ky="0" algn="bl" rotWithShape="0" blurRad="76200" dist="381" dir="5400000">
+              <a:srgbClr val="000000">
+                <a:alpha val="8000"/>
+              </a:srgbClr>
+            </a:outerShdw>
+          </a:effectLst>
+        </p:spPr>
+      </p:sp>
+      <p:sp>
+        <p:nvSpPr>
+          <p:cNvPr id="11" name="Text 9"/>
+          <p:cNvSpPr/>
+          <p:nvPr/>
+        </p:nvSpPr>
+        <p:spPr>
+          <a:xfrm>
+            <a:off x="841248" y="4791456"/>
+            <a:ext cx="10479024" cy="274320"/>
+          </a:xfrm>
+          <a:prstGeom prst="rect">
+            <a:avLst/>
+          </a:prstGeom>
+          <a:noFill/>
+          <a:ln/>
+        </p:spPr>
+        <p:txBody>
+          <a:bodyPr wrap="square" lIns="0" tIns="0" rIns="0" bIns="0" rtlCol="0" anchor="ctr"/>
+          <a:lstStyle/>
+          <a:p>
+            <a:pPr indent="0" marL="0">
+              <a:buNone/>
+            </a:pPr>
+            <a:r>
+              <a:rPr lang="en-US" sz="1200" b="1" dirty="0">
+                <a:solidFill>
+                  <a:srgbClr val="2B2523"/>
+                </a:solidFill>
+                <a:latin typeface="Cambria" pitchFamily="34" charset="0"/>
+                <a:ea typeface="Cambria" pitchFamily="34" charset="-122"/>
+                <a:cs typeface="Cambria" pitchFamily="34" charset="-120"/>
+              </a:rPr>
+              <a:t>A first pass has already been run, informally</a:t>
+            </a:r>
+            <a:endParaRPr lang="en-US" sz="1200" dirty="0"/>
+          </a:p>
+        </p:txBody>
+      </p:sp>
+      <p:sp>
+        <p:nvSpPr>
+          <p:cNvPr id="12" name="Text 10"/>
+          <p:cNvSpPr/>
+          <p:nvPr/>
+        </p:nvSpPr>
+        <p:spPr>
+          <a:xfrm>
+            <a:off x="841248" y="5084064"/>
+            <a:ext cx="10479024" cy="914400"/>
+          </a:xfrm>
+          <a:prstGeom prst="rect">
+            <a:avLst/>
+          </a:prstGeom>
+          <a:noFill/>
+          <a:ln/>
+        </p:spPr>
+        <p:txBody>
+          <a:bodyPr wrap="square" lIns="0" tIns="0" rIns="0" bIns="0" rtlCol="0" anchor="ctr"/>
+          <a:lstStyle/>
+          <a:p>
+            <a:pPr indent="0" marL="0">
+              <a:lnSpc>
+                <a:spcPts val="1400"/>
+              </a:lnSpc>
+              <a:buNone/>
+            </a:pPr>
+            <a:r>
+              <a:rPr lang="en-US" sz="1050" i="1" dirty="0">
+                <a:solidFill>
+                  <a:srgbClr val="2B2523"/>
+                </a:solidFill>
+                <a:latin typeface="Calibri" pitchFamily="34" charset="0"/>
+                <a:ea typeface="Calibri" pitchFamily="34" charset="-122"/>
+                <a:cs typeface="Calibri" pitchFamily="34" charset="-120"/>
+              </a:rPr>
+              <a:t>48.9% of conflict-severe district-months with market data were also market-stressed, against a 35.8% baseline; a first significance test came out borderline (p = 0.074). Promising, but not yet trustworthy: the district-level robustness check above still needs to be run before this can be reported as a real finding.</a:t>
+            </a:r>
+            <a:endParaRPr lang="en-US" sz="1050" dirty="0"/>
+          </a:p>
+        </p:txBody>
+      </p:sp>
+    </p:spTree>
+  </p:cSld>
+  <p:clrMapOvr>
+    <a:masterClrMapping/>
+  </p:clrMapOvr>
+</p:sld>
+</file>
+
+<file path=ppt/slides/slide34.xml><?xml version="1.0" encoding="utf-8"?>
+<p:sld xmlns:a="http://schemas.openxmlformats.org/drawingml/2006/main" xmlns:r="http://schemas.openxmlformats.org/officeDocument/2006/relationships" xmlns:p="http://schemas.openxmlformats.org/presentationml/2006/main">
+  <p:cSld name="Slide 34">
+    <p:bg>
+      <p:bgPr>
+        <a:solidFill>
+          <a:srgbClr val="FFFFFF"/>
+        </a:solidFill>
+      </p:bgPr>
+    </p:bg>
+    <p:spTree>
+      <p:nvGrpSpPr>
+        <p:cNvPr id="1" name=""/>
+        <p:cNvGrpSpPr/>
+        <p:nvPr/>
+      </p:nvGrpSpPr>
+      <p:grpSpPr>
+        <a:xfrm>
+          <a:off x="0" y="0"/>
+          <a:ext cx="0" cy="0"/>
+          <a:chOff x="0" y="0"/>
+          <a:chExt cx="0" cy="0"/>
+        </a:xfrm>
+      </p:grpSpPr>
+      <p:sp>
+        <p:nvSpPr>
+          <p:cNvPr id="2" name="Text 0"/>
+          <p:cNvSpPr/>
+          <p:nvPr/>
+        </p:nvSpPr>
+        <p:spPr>
+          <a:xfrm>
+            <a:off x="566928" y="457200"/>
+            <a:ext cx="11027664" cy="548640"/>
+          </a:xfrm>
+          <a:prstGeom prst="rect">
+            <a:avLst/>
+          </a:prstGeom>
+          <a:noFill/>
+          <a:ln/>
+        </p:spPr>
+        <p:txBody>
+          <a:bodyPr wrap="square" lIns="0" tIns="0" rIns="0" bIns="0" rtlCol="0" anchor="ctr"/>
+          <a:lstStyle/>
+          <a:p>
+            <a:pPr indent="0" marL="0">
+              <a:buNone/>
+            </a:pPr>
+            <a:r>
+              <a:rPr lang="en-US" sz="2500" b="1" dirty="0">
+                <a:solidFill>
+                  <a:srgbClr val="2B2523"/>
+                </a:solidFill>
+                <a:latin typeface="Cambria" pitchFamily="34" charset="0"/>
+                <a:ea typeface="Cambria" pitchFamily="34" charset="-122"/>
+                <a:cs typeface="Cambria" pitchFamily="34" charset="-120"/>
+              </a:rPr>
+              <a:t>Next steps, part 2: new analysis still to run (4 of 4)</a:t>
+            </a:r>
+            <a:endParaRPr lang="en-US" sz="2500" dirty="0"/>
+          </a:p>
+        </p:txBody>
+      </p:sp>
+      <p:sp>
+        <p:nvSpPr>
+          <p:cNvPr id="3" name="Text 1"/>
+          <p:cNvSpPr/>
+          <p:nvPr/>
+        </p:nvSpPr>
+        <p:spPr>
+          <a:xfrm>
+            <a:off x="566928" y="987552"/>
+            <a:ext cx="11027664" cy="329184"/>
+          </a:xfrm>
+          <a:prstGeom prst="rect">
+            <a:avLst/>
+          </a:prstGeom>
+          <a:noFill/>
+          <a:ln/>
+        </p:spPr>
+        <p:txBody>
+          <a:bodyPr wrap="square" lIns="0" tIns="0" rIns="0" bIns="0" rtlCol="0" anchor="ctr"/>
+          <a:lstStyle/>
+          <a:p>
+            <a:pPr indent="0" marL="0">
+              <a:buNone/>
+            </a:pPr>
+            <a:r>
+              <a:rPr lang="en-US" sz="1250" i="1" dirty="0">
+                <a:solidFill>
+                  <a:srgbClr val="7A6E68"/>
+                </a:solidFill>
+                <a:latin typeface="Calibri" pitchFamily="34" charset="0"/>
+                <a:ea typeface="Calibri" pitchFamily="34" charset="-122"/>
+                <a:cs typeface="Calibri" pitchFamily="34" charset="-120"/>
+              </a:rPr>
+              <a:t>A note on how fine-grained each source is</a:t>
+            </a:r>
+            <a:endParaRPr lang="en-US" sz="1250" dirty="0"/>
+          </a:p>
+        </p:txBody>
+      </p:sp>
+      <p:sp>
+        <p:nvSpPr>
+          <p:cNvPr id="4" name="Shape 2"/>
+          <p:cNvSpPr/>
+          <p:nvPr/>
+        </p:nvSpPr>
+        <p:spPr>
+          <a:xfrm>
+            <a:off x="566928" y="1517904"/>
+            <a:ext cx="11027664" cy="1188720"/>
+          </a:xfrm>
+          <a:prstGeom prst="roundRect">
+            <a:avLst>
+              <a:gd name="adj" fmla="val 4615"/>
+            </a:avLst>
+          </a:prstGeom>
+          <a:solidFill>
+            <a:srgbClr val="2B2523"/>
+          </a:solidFill>
+          <a:ln/>
+          <a:effectLst>
+            <a:outerShdw sx="100000" sy="100000" kx="0" ky="0" algn="bl" rotWithShape="0" blurRad="76200" dist="381" dir="5400000">
+              <a:srgbClr val="000000">
+                <a:alpha val="8000"/>
+              </a:srgbClr>
+            </a:outerShdw>
+          </a:effectLst>
+        </p:spPr>
+      </p:sp>
+      <p:sp>
+        <p:nvSpPr>
+          <p:cNvPr id="5" name="Text 3"/>
+          <p:cNvSpPr/>
+          <p:nvPr/>
+        </p:nvSpPr>
+        <p:spPr>
+          <a:xfrm>
+            <a:off x="841248" y="1645920"/>
+            <a:ext cx="10479024" cy="274320"/>
+          </a:xfrm>
+          <a:prstGeom prst="rect">
+            <a:avLst/>
+          </a:prstGeom>
+          <a:noFill/>
+          <a:ln/>
+        </p:spPr>
+        <p:txBody>
+          <a:bodyPr wrap="square" lIns="0" tIns="0" rIns="0" bIns="0" rtlCol="0" anchor="ctr"/>
+          <a:lstStyle/>
+          <a:p>
+            <a:pPr indent="0" marL="0">
+              <a:buNone/>
+            </a:pPr>
+            <a:r>
+              <a:rPr lang="en-US" sz="1300" b="1" dirty="0">
+                <a:solidFill>
+                  <a:srgbClr val="A7BEAE"/>
+                </a:solidFill>
+                <a:latin typeface="Cambria" pitchFamily="34" charset="0"/>
+                <a:ea typeface="Cambria" pitchFamily="34" charset="-122"/>
+                <a:cs typeface="Cambria" pitchFamily="34" charset="-120"/>
+              </a:rPr>
+              <a:t>Why</a:t>
+            </a:r>
+            <a:endParaRPr lang="en-US" sz="1300" dirty="0"/>
+          </a:p>
+        </p:txBody>
+      </p:sp>
+      <p:sp>
+        <p:nvSpPr>
+          <p:cNvPr id="6" name="Text 4"/>
+          <p:cNvSpPr/>
+          <p:nvPr/>
+        </p:nvSpPr>
+        <p:spPr>
+          <a:xfrm>
+            <a:off x="841248" y="1920240"/>
+            <a:ext cx="10479024" cy="731520"/>
+          </a:xfrm>
+          <a:prstGeom prst="rect">
+            <a:avLst/>
+          </a:prstGeom>
+          <a:noFill/>
+          <a:ln/>
+        </p:spPr>
+        <p:txBody>
+          <a:bodyPr wrap="square" lIns="0" tIns="0" rIns="0" bIns="0" rtlCol="0" anchor="ctr"/>
+          <a:lstStyle/>
+          <a:p>
+            <a:pPr indent="0" marL="0">
+              <a:lnSpc>
+                <a:spcPts val="1500"/>
+              </a:lnSpc>
+              <a:buNone/>
+            </a:pPr>
+            <a:r>
+              <a:rPr lang="en-US" sz="1150" dirty="0">
+                <a:solidFill>
+                  <a:srgbClr val="E7E8D1"/>
+                </a:solidFill>
+                <a:latin typeface="Calibri" pitchFamily="34" charset="0"/>
+                <a:ea typeface="Calibri" pitchFamily="34" charset="-122"/>
+                <a:cs typeface="Calibri" pitchFamily="34" charset="-120"/>
+              </a:rPr>
+              <a:t>The research question names "granularity" specifically, alongside coverage, missingness and measurement reliability. Nothing in the notebook addresses it head-on: all four sources end up as one number per district per month, but they start at very different levels of detail.</a:t>
+            </a:r>
+            <a:endParaRPr lang="en-US" sz="1150" dirty="0"/>
+          </a:p>
+        </p:txBody>
+      </p:sp>
+      <p:sp>
+        <p:nvSpPr>
+          <p:cNvPr id="7" name="Shape 5"/>
+          <p:cNvSpPr/>
+          <p:nvPr/>
+        </p:nvSpPr>
+        <p:spPr>
+          <a:xfrm>
+            <a:off x="566928" y="2889504"/>
+            <a:ext cx="11027664" cy="2377440"/>
+          </a:xfrm>
+          <a:prstGeom prst="roundRect">
+            <a:avLst>
+              <a:gd name="adj" fmla="val 2308"/>
+            </a:avLst>
+          </a:prstGeom>
+          <a:solidFill>
+            <a:srgbClr val="F7F5F1"/>
+          </a:solidFill>
+          <a:ln/>
+          <a:effectLst>
+            <a:outerShdw sx="100000" sy="100000" kx="0" ky="0" algn="bl" rotWithShape="0" blurRad="76200" dist="381" dir="5400000">
+              <a:srgbClr val="000000">
+                <a:alpha val="8000"/>
+              </a:srgbClr>
+            </a:outerShdw>
+          </a:effectLst>
+        </p:spPr>
+      </p:sp>
+      <p:sp>
+        <p:nvSpPr>
+          <p:cNvPr id="8" name="Text 6"/>
+          <p:cNvSpPr/>
+          <p:nvPr/>
+        </p:nvSpPr>
+        <p:spPr>
+          <a:xfrm>
+            <a:off x="841248" y="3017520"/>
+            <a:ext cx="10479024" cy="274320"/>
+          </a:xfrm>
+          <a:prstGeom prst="rect">
+            <a:avLst/>
+          </a:prstGeom>
+          <a:noFill/>
+          <a:ln/>
+        </p:spPr>
+        <p:txBody>
+          <a:bodyPr wrap="square" lIns="0" tIns="0" rIns="0" bIns="0" rtlCol="0" anchor="ctr"/>
+          <a:lstStyle/>
+          <a:p>
+            <a:pPr indent="0" marL="0">
+              <a:buNone/>
+            </a:pPr>
+            <a:r>
+              <a:rPr lang="en-US" sz="1300" b="1" dirty="0">
+                <a:solidFill>
+                  <a:srgbClr val="B85042"/>
+                </a:solidFill>
+                <a:latin typeface="Cambria" pitchFamily="34" charset="0"/>
+                <a:ea typeface="Cambria" pitchFamily="34" charset="-122"/>
+                <a:cs typeface="Cambria" pitchFamily="34" charset="-120"/>
+              </a:rPr>
+              <a:t>What we will actually do</a:t>
+            </a:r>
+            <a:endParaRPr lang="en-US" sz="1300" dirty="0"/>
+          </a:p>
+        </p:txBody>
+      </p:sp>
+      <p:sp>
+        <p:nvSpPr>
+          <p:cNvPr id="9" name="Text 7"/>
+          <p:cNvSpPr/>
+          <p:nvPr/>
+        </p:nvSpPr>
+        <p:spPr>
+          <a:xfrm>
+            <a:off x="841248" y="3310128"/>
+            <a:ext cx="10479024" cy="457200"/>
+          </a:xfrm>
+          <a:prstGeom prst="rect">
+            <a:avLst/>
+          </a:prstGeom>
+          <a:noFill/>
+          <a:ln/>
+        </p:spPr>
+        <p:txBody>
+          <a:bodyPr wrap="square" lIns="0" tIns="0" rIns="0" bIns="0" rtlCol="0" anchor="ctr"/>
+          <a:lstStyle/>
+          <a:p>
+            <a:pPr indent="0" marL="0">
+              <a:lnSpc>
+                <a:spcPts val="1400"/>
+              </a:lnSpc>
+              <a:buNone/>
+            </a:pPr>
+            <a:r>
+              <a:rPr lang="en-US" sz="1100" dirty="0">
+                <a:solidFill>
+                  <a:srgbClr val="7A6E68"/>
+                </a:solidFill>
+                <a:latin typeface="Calibri" pitchFamily="34" charset="0"/>
+                <a:ea typeface="Calibri" pitchFamily="34" charset="-122"/>
+                <a:cs typeface="Calibri" pitchFamily="34" charset="-120"/>
+              </a:rPr>
+              <a:t>This one is documentation, not statistical analysis. Each source's native resolution before it collapses to one district-level number will be written up as a short comparison, already partially checked directly against the raw files:</a:t>
+            </a:r>
+            <a:endParaRPr lang="en-US" sz="1100" dirty="0"/>
+          </a:p>
+        </p:txBody>
+      </p:sp>
+      <p:sp>
+        <p:nvSpPr>
+          <p:cNvPr id="10" name="Text 8"/>
+          <p:cNvSpPr/>
+          <p:nvPr/>
+        </p:nvSpPr>
+        <p:spPr>
+          <a:xfrm>
+            <a:off x="841248" y="3840480"/>
+            <a:ext cx="10479024" cy="1371600"/>
+          </a:xfrm>
+          <a:prstGeom prst="rect">
+            <a:avLst/>
+          </a:prstGeom>
+          <a:noFill/>
+          <a:ln/>
+        </p:spPr>
+        <p:txBody>
+          <a:bodyPr wrap="square" lIns="0" tIns="0" rIns="0" bIns="0" rtlCol="0" anchor="ctr"/>
+          <a:lstStyle/>
+          <a:p>
+            <a:pPr marL="342900" indent="-342900">
+              <a:lnSpc>
+                <a:spcPts val="1300"/>
+              </a:lnSpc>
+              <a:spcAft>
+                <a:spcPts val="700"/>
+              </a:spcAft>
+              <a:buSzPct val="100000"/>
+              <a:buChar char="•"/>
+            </a:pPr>
+            <a:r>
+              <a:rPr lang="en-US" sz="1050" dirty="0">
+                <a:solidFill>
+                  <a:srgbClr val="7A6E68"/>
+                </a:solidFill>
+                <a:latin typeface="Calibri" pitchFamily="34" charset="0"/>
+                <a:ea typeface="Calibri" pitchFamily="34" charset="-122"/>
+                <a:cs typeface="Calibri" pitchFamily="34" charset="-120"/>
+              </a:rPr>
+              <a:t>Conflict: each event is an exact GPS point (confirmed: ACLED carries latitude/longitude for every record)</a:t>
+            </a:r>
+            <a:endParaRPr lang="en-US" sz="1050" dirty="0"/>
+          </a:p>
+          <a:p>
+            <a:pPr marL="342900" indent="-342900">
+              <a:lnSpc>
+                <a:spcPts val="1300"/>
+              </a:lnSpc>
+              <a:spcAft>
+                <a:spcPts val="700"/>
+              </a:spcAft>
+              <a:buSzPct val="100000"/>
+              <a:buChar char="•"/>
+            </a:pPr>
+            <a:r>
+              <a:rPr lang="en-US" sz="1050" dirty="0">
+                <a:solidFill>
+                  <a:srgbClr val="7A6E68"/>
+                </a:solidFill>
+                <a:latin typeface="Calibri" pitchFamily="34" charset="0"/>
+                <a:ea typeface="Calibri" pitchFamily="34" charset="-122"/>
+                <a:cs typeface="Calibri" pitchFamily="34" charset="-120"/>
+              </a:rPr>
+              <a:t>Climate: satellite grid cells, confirmed directly from the raster files: CHIRPS at 0.05 degrees (~5.5km), VHI at 0.036 degrees (~4km)</a:t>
+            </a:r>
+            <a:endParaRPr lang="en-US" sz="1050" dirty="0"/>
+          </a:p>
+          <a:p>
+            <a:pPr marL="342900" indent="-342900">
+              <a:lnSpc>
+                <a:spcPts val="1300"/>
+              </a:lnSpc>
+              <a:spcAft>
+                <a:spcPts val="700"/>
+              </a:spcAft>
+              <a:buSzPct val="100000"/>
+              <a:buChar char="•"/>
+            </a:pPr>
+            <a:r>
+              <a:rPr lang="en-US" sz="1050" dirty="0">
+                <a:solidFill>
+                  <a:srgbClr val="7A6E68"/>
+                </a:solidFill>
+                <a:latin typeface="Calibri" pitchFamily="34" charset="0"/>
+                <a:ea typeface="Calibri" pitchFamily="34" charset="-122"/>
+                <a:cs typeface="Calibri" pitchFamily="34" charset="-120"/>
+              </a:rPr>
+              <a:t>Market: a specific, named market stall or stand</a:t>
+            </a:r>
+            <a:endParaRPr lang="en-US" sz="1050" dirty="0"/>
+          </a:p>
+          <a:p>
+            <a:pPr marL="342900" indent="-342900">
+              <a:lnSpc>
+                <a:spcPts val="1300"/>
+              </a:lnSpc>
+              <a:spcAft>
+                <a:spcPts val="700"/>
+              </a:spcAft>
+              <a:buSzPct val="100000"/>
+              <a:buChar char="•"/>
+            </a:pPr>
+            <a:r>
+              <a:rPr lang="en-US" sz="1050" dirty="0">
+                <a:solidFill>
+                  <a:srgbClr val="7A6E68"/>
+                </a:solidFill>
+                <a:latin typeface="Calibri" pitchFamily="34" charset="0"/>
+                <a:ea typeface="Calibri" pitchFamily="34" charset="-122"/>
+                <a:cs typeface="Calibri" pitchFamily="34" charset="-120"/>
+              </a:rPr>
+              <a:t>Reporting: a whole document; the geoparser can say a report mentions a district, never anything more precise than that</a:t>
+            </a:r>
+            <a:endParaRPr lang="en-US" sz="1050" dirty="0"/>
+          </a:p>
+        </p:txBody>
+      </p:sp>
+      <p:sp>
+        <p:nvSpPr>
+          <p:cNvPr id="11" name="Text 9"/>
+          <p:cNvSpPr/>
+          <p:nvPr/>
+        </p:nvSpPr>
+        <p:spPr>
+          <a:xfrm>
+            <a:off x="566928" y="6144768"/>
+            <a:ext cx="11027664" cy="237744"/>
+          </a:xfrm>
+          <a:prstGeom prst="rect">
+            <a:avLst/>
+          </a:prstGeom>
+          <a:noFill/>
+          <a:ln/>
+        </p:spPr>
+        <p:txBody>
+          <a:bodyPr wrap="square" lIns="0" tIns="0" rIns="0" bIns="0" rtlCol="0" anchor="ctr"/>
+          <a:lstStyle/>
+          <a:p>
+            <a:pPr indent="0" marL="0">
+              <a:buNone/>
+            </a:pPr>
+            <a:r>
+              <a:rPr lang="en-US" sz="900" i="1" dirty="0">
+                <a:solidFill>
+                  <a:srgbClr val="7A6E68"/>
+                </a:solidFill>
+                <a:latin typeface="Calibri" pitchFamily="34" charset="0"/>
+                <a:ea typeface="Calibri" pitchFamily="34" charset="-122"/>
+                <a:cs typeface="Calibri" pitchFamily="34" charset="-120"/>
+              </a:rPr>
+              <a:t>Slots into the existing source-level table as an added row.</a:t>
+            </a:r>
+            <a:endParaRPr lang="en-US" sz="900" dirty="0"/>
           </a:p>
         </p:txBody>
       </p:sp>

</xml_diff>